<commit_message>
Update tutorial deck for the canonical GCAM-HPC workflow
Replace deprecated setup and pipeline names, document manual source upload and two-stage dependency extraction, align QUERY-before-RUN guidance, and refresh the RUN and QUERY visuals.

Co-Authored-By: Codex <noreply@openai.com>
</commit_message>
<xml_diff>
--- a/asset/tutorial/gcam-hpc-tutorial.pptx
+++ b/asset/tutorial/gcam-hpc-tutorial.pptx
@@ -2334,29 +2334,29 @@
                 <a:latin typeface="Arial"/>
                 <a:ea typeface="微软雅黑"/>
               </a:rPr>
-              <a:t>提交 RUN 前先生成查询 XML，并让 xmldb_batch.xml 指向它。运行时，每个 run_model.sh 任务在 gcam.exe 结束后调用 ModelInterface，执行这组预配置查询并导出 CSV。</a:t>
+              <a:t>RUN 前生成 queries-*.xml，并由 modelinterface-batch.xml 引用；每个情景在 gcam.exe 后自动执行同一组 QUERY 并输出 CSV。</a:t>
             </a:r>
           </a:p>
         </p:txBody>
       </p:sp>
       <p:pic>
         <p:nvPicPr>
-          <p:cNvPr id="100089" name="Picture 1"/>
+          <p:cNvPr id="100089" name="Picture 1" descr="GCAM-HPC RUN and QUERY pipeline"/>
           <p:cNvPicPr>
             <a:picLocks xmlns:a="http://schemas.openxmlformats.org/drawingml/2006/main" noChangeAspect="1"/>
           </p:cNvPicPr>
           <p:nvPr/>
         </p:nvPicPr>
         <p:blipFill>
-          <a:blip xmlns:r="http://schemas.openxmlformats.org/officeDocument/2006/relationships" xmlns:a="http://schemas.openxmlformats.org/drawingml/2006/main" r:embed="R61a33ff7bef845be"/>
+          <a:blip xmlns:r="http://schemas.openxmlformats.org/officeDocument/2006/relationships" xmlns:a="http://schemas.openxmlformats.org/drawingml/2006/main" r:embed="R1a0b2e73a1f64d79"/>
           <a:stretch xmlns:a="http://schemas.openxmlformats.org/drawingml/2006/main">
             <a:fillRect/>
           </a:stretch>
         </p:blipFill>
         <p:spPr>
           <a:xfrm xmlns:a="http://schemas.openxmlformats.org/drawingml/2006/main">
-            <a:off x="2571000" y="1720000"/>
-            <a:ext cx="7050000" cy="4218787"/>
+            <a:off x="1152000" y="1476000"/>
+            <a:ext cx="9900000" cy="4950000"/>
           </a:xfrm>
           <a:prstGeom xmlns:a="http://schemas.openxmlformats.org/drawingml/2006/main" prst="rect">
             <a:avLst/>
@@ -2371,7 +2371,7 @@
         </p:nvSpPr>
         <p:spPr>
           <a:xfrm xmlns:a="http://schemas.openxmlformats.org/drawingml/2006/main">
-            <a:off x="2571000" y="5968787"/>
+            <a:off x="2571000" y="6444000"/>
             <a:ext cx="7050000" cy="320000"/>
           </a:xfrm>
           <a:prstGeom xmlns:a="http://schemas.openxmlformats.org/drawingml/2006/main" prst="rect">
@@ -2399,7 +2399,7 @@
                 <a:latin typeface="Arial"/>
                 <a:ea typeface="微软雅黑"/>
               </a:rPr>
-              <a:t>GCAM-PKU-HPC 查询流程</a:t>
+              <a:t>GCAM-HPC：RUN + QUERY 自动编排</a:t>
             </a:r>
           </a:p>
         </p:txBody>
@@ -2538,7 +2538,9 @@
           <a:noFill xmlns:a="http://schemas.openxmlformats.org/drawingml/2006/main"/>
         </p:spPr>
         <p:txBody>
-          <a:bodyPr xmlns:a="http://schemas.openxmlformats.org/drawingml/2006/main" wrap="square" anchor="t"/>
+          <a:bodyPr xmlns:a="http://schemas.openxmlformats.org/drawingml/2006/main" wrap="square" anchor="t">
+            <a:normAutofit/>
+          </a:bodyPr>
           <a:lstStyle xmlns:a="http://schemas.openxmlformats.org/drawingml/2006/main"/>
           <a:p xmlns:a="http://schemas.openxmlformats.org/drawingml/2006/main">
             <a:pPr algn="l">
@@ -2557,7 +2559,7 @@
                 <a:latin typeface="Arial"/>
                 <a:ea typeface="微软雅黑"/>
               </a:rPr>
-              <a:t>1 · 生成用户批量查询（二选一，等价）</a:t>
+              <a:t>1 · 生成用户批量查询</a:t>
             </a:r>
           </a:p>
         </p:txBody>
@@ -2586,9 +2588,11 @@
           </a:ln>
         </p:spPr>
         <p:txBody>
-          <a:bodyPr xmlns:a="http://schemas.openxmlformats.org/drawingml/2006/main" wrap="square" lIns="146304" tIns="146304" rIns="146304" bIns="146304" anchor="t"/>
-          <a:lstStyle xmlns:a="http://schemas.openxmlformats.org/drawingml/2006/main"/>
-          <a:p xmlns:a="http://schemas.openxmlformats.org/drawingml/2006/main">
+          <a:bodyPr xmlns:a="http://schemas.openxmlformats.org/drawingml/2006/main" wrap="square" lIns="146304" tIns="146304" rIns="146304" bIns="146304" anchor="t">
+            <a:normAutofit/>
+          </a:bodyPr>
+          <a:lstStyle xmlns:a="http://schemas.openxmlformats.org/drawingml/2006/main"/>
+          <a:p>
             <a:pPr algn="l">
               <a:lnSpc>
                 <a:spcPct val="115000"/>
@@ -2598,7 +2602,7 @@
               </a:spcAft>
             </a:pPr>
             <a:r>
-              <a:rPr lang="en-US" sz="1250" b="0">
+              <a:rPr lang="en-US" sz="1150" b="0">
                 <a:solidFill>
                   <a:srgbClr val="1A1A1A"/>
                 </a:solidFill>
@@ -2608,7 +2612,7 @@
               <a:t>query-tools/batch_query_generator/</a:t>
             </a:r>
           </a:p>
-          <a:p xmlns:a="http://schemas.openxmlformats.org/drawingml/2006/main">
+          <a:p>
             <a:pPr algn="l">
               <a:lnSpc>
                 <a:spcPct val="115000"/>
@@ -2618,17 +2622,17 @@
               </a:spcAft>
             </a:pPr>
             <a:r>
-              <a:rPr lang="en-US" sz="1250" b="0">
+              <a:rPr lang="en-US" sz="1150" b="0">
                 <a:solidFill>
                   <a:srgbClr val="1A1A1A"/>
                 </a:solidFill>
                 <a:latin typeface="Consolas"/>
                 <a:ea typeface="Consolas"/>
               </a:rPr>
-              <a:t>  create_batch_query_generator.ipynb   # Notebook</a:t>
-            </a:r>
-          </a:p>
-          <a:p xmlns:a="http://schemas.openxmlformats.org/drawingml/2006/main">
+              <a:t xml:space="preserve">  query-config.yaml                 # 选择 regions / queries</a:t>
+            </a:r>
+          </a:p>
+          <a:p>
             <a:pPr algn="l">
               <a:lnSpc>
                 <a:spcPct val="115000"/>
@@ -2638,14 +2642,34 @@
               </a:spcAft>
             </a:pPr>
             <a:r>
-              <a:rPr lang="en-US" sz="1250" b="0">
+              <a:rPr lang="en-US" sz="1150" b="0">
                 <a:solidFill>
                   <a:srgbClr val="1A1A1A"/>
                 </a:solidFill>
                 <a:latin typeface="Consolas"/>
                 <a:ea typeface="Consolas"/>
               </a:rPr>
-              <a:t>  create_batch_query_tools.py          # 脚本</a:t>
+              <a:t xml:space="preserve">  build_queries.py                  # Python CLI</a:t>
+            </a:r>
+          </a:p>
+          <a:p>
+            <a:pPr algn="l">
+              <a:lnSpc>
+                <a:spcPct val="115000"/>
+              </a:lnSpc>
+              <a:spcAft>
+                <a:spcPts val="0"/>
+              </a:spcAft>
+            </a:pPr>
+            <a:r>
+              <a:rPr lang="en-US" sz="1150" b="0">
+                <a:solidFill>
+                  <a:srgbClr val="1A1A1A"/>
+                </a:solidFill>
+                <a:latin typeface="Consolas"/>
+                <a:ea typeface="Consolas"/>
+              </a:rPr>
+              <a:t xml:space="preserve">  interactive-query-builder.ipynb   # Notebook</a:t>
             </a:r>
           </a:p>
         </p:txBody>
@@ -2667,9 +2691,11 @@
           <a:noFill xmlns:a="http://schemas.openxmlformats.org/drawingml/2006/main"/>
         </p:spPr>
         <p:txBody>
-          <a:bodyPr xmlns:a="http://schemas.openxmlformats.org/drawingml/2006/main" wrap="square" anchor="t"/>
-          <a:lstStyle xmlns:a="http://schemas.openxmlformats.org/drawingml/2006/main"/>
-          <a:p xmlns:a="http://schemas.openxmlformats.org/drawingml/2006/main">
+          <a:bodyPr xmlns:a="http://schemas.openxmlformats.org/drawingml/2006/main" wrap="square" anchor="t">
+            <a:normAutofit/>
+          </a:bodyPr>
+          <a:lstStyle xmlns:a="http://schemas.openxmlformats.org/drawingml/2006/main"/>
+          <a:p>
             <a:pPr algn="l">
               <a:lnSpc>
                 <a:spcPct val="135000"/>
@@ -2686,10 +2712,10 @@
                 <a:latin typeface="Arial"/>
                 <a:ea typeface="微软雅黑"/>
               </a:rPr>
-              <a:t>关键函数：</a:t>
-            </a:r>
-          </a:p>
-          <a:p xmlns:a="http://schemas.openxmlformats.org/drawingml/2006/main">
+              <a:t>查询定义：</a:t>
+            </a:r>
+          </a:p>
+          <a:p>
             <a:pPr algn="l">
               <a:lnSpc>
                 <a:spcPct val="135000"/>
@@ -2706,10 +2732,10 @@
                 <a:latin typeface="Arial"/>
                 <a:ea typeface="微软雅黑"/>
               </a:rPr>
-              <a:t>read_regions_from_csv() · build_query_xml()</a:t>
-            </a:r>
-          </a:p>
-          <a:p xmlns:a="http://schemas.openxmlformats.org/drawingml/2006/main">
+              <a:t>query-definitions/main-queries.xml</a:t>
+            </a:r>
+          </a:p>
+          <a:p>
             <a:pPr algn="l">
               <a:lnSpc>
                 <a:spcPct val="135000"/>
@@ -2726,10 +2752,10 @@
                 <a:latin typeface="Arial"/>
                 <a:ea typeface="微软雅黑"/>
               </a:rPr>
-              <a:t>select_queries_and_regions()</a:t>
-            </a:r>
-          </a:p>
-          <a:p xmlns:a="http://schemas.openxmlformats.org/drawingml/2006/main">
+              <a:t>query-definitions/share-weight-query.xml</a:t>
+            </a:r>
+          </a:p>
+          <a:p>
             <a:pPr algn="l">
               <a:lnSpc>
                 <a:spcPct val="135000"/>
@@ -2746,7 +2772,27 @@
                 <a:latin typeface="Arial"/>
                 <a:ea typeface="微软雅黑"/>
               </a:rPr>
-              <a:t>→ 输出 output_queries_&lt;timestamp&gt;.xml</a:t>
+              <a:t/>
+            </a:r>
+          </a:p>
+          <a:p>
+            <a:pPr algn="l">
+              <a:lnSpc>
+                <a:spcPct val="135000"/>
+              </a:lnSpc>
+              <a:spcAft>
+                <a:spcPts val="0"/>
+              </a:spcAft>
+            </a:pPr>
+            <a:r>
+              <a:rPr lang="en-US" sz="1300" b="0">
+                <a:solidFill>
+                  <a:srgbClr val="333333"/>
+                </a:solidFill>
+                <a:latin typeface="Arial"/>
+                <a:ea typeface="微软雅黑"/>
+              </a:rPr>
+              <a:t>→ 输出 user_batch_queries/queries-&lt;timestamp&gt;.xml</a:t>
             </a:r>
           </a:p>
         </p:txBody>
@@ -2787,7 +2833,7 @@
                 <a:latin typeface="Arial"/>
                 <a:ea typeface="微软雅黑"/>
               </a:rPr>
-              <a:t>微调时可直接编辑 queries_xml/Main_queries.xml 中的 &lt;supplyDemandQuery&gt; 条目。</a:t>
+              <a:t>queries-*.xml 是本地用户配置，已被 Git 忽略；提交 RUN 前必须先生成。</a:t>
             </a:r>
           </a:p>
         </p:txBody>
@@ -2852,7 +2898,7 @@
                 <a:latin typeface="Arial"/>
                 <a:ea typeface="微软雅黑"/>
               </a:rPr>
-              <a:t>批量查询生成器 create_batch_query_generator</a:t>
+              <a:t>交互式 QUERY 生成器</a:t>
             </a:r>
           </a:p>
         </p:txBody>
@@ -2874,7 +2920,9 @@
           <a:noFill xmlns:a="http://schemas.openxmlformats.org/drawingml/2006/main"/>
         </p:spPr>
         <p:txBody>
-          <a:bodyPr xmlns:a="http://schemas.openxmlformats.org/drawingml/2006/main" wrap="square" anchor="t"/>
+          <a:bodyPr xmlns:a="http://schemas.openxmlformats.org/drawingml/2006/main" wrap="square" anchor="t">
+            <a:normAutofit/>
+          </a:bodyPr>
           <a:lstStyle xmlns:a="http://schemas.openxmlformats.org/drawingml/2006/main"/>
           <a:p xmlns:a="http://schemas.openxmlformats.org/drawingml/2006/main">
             <a:pPr algn="l">
@@ -2893,7 +2941,7 @@
                 <a:latin typeface="Arial"/>
                 <a:ea typeface="微软雅黑"/>
               </a:rPr>
-              <a:t>2 · 让 xmldb_batch.xml 指向将被同步的查询文件</a:t>
+              <a:t>2 · 配置 modelinterface-batch.xml</a:t>
             </a:r>
           </a:p>
         </p:txBody>
@@ -2934,7 +2982,7 @@
                 <a:latin typeface="Arial"/>
                 <a:ea typeface="微软雅黑"/>
               </a:rPr>
-              <a:t>master.sh 在提交前把 user_batch_queries/ 同步到 scratch/output/xmldb_queries/；&lt;queryFile&gt; 必须指向该目录内文件。</a:t>
+              <a:t>run-pipeline.sh 将 user_batch_queries/ 同步到 scratch/output/xmldb_queries/；&lt;queryFile&gt; 必须指向同步后的文件。</a:t>
             </a:r>
           </a:p>
         </p:txBody>
@@ -2963,7 +3011,9 @@
           </a:ln>
         </p:spPr>
         <p:txBody>
-          <a:bodyPr xmlns:a="http://schemas.openxmlformats.org/drawingml/2006/main" wrap="square" lIns="146304" tIns="146304" rIns="146304" bIns="146304" anchor="t"/>
+          <a:bodyPr xmlns:a="http://schemas.openxmlformats.org/drawingml/2006/main" wrap="square" lIns="146304" tIns="146304" rIns="146304" bIns="146304" anchor="t">
+            <a:normAutofit/>
+          </a:bodyPr>
           <a:lstStyle xmlns:a="http://schemas.openxmlformats.org/drawingml/2006/main"/>
           <a:p xmlns:a="http://schemas.openxmlformats.org/drawingml/2006/main">
             <a:pPr algn="l">
@@ -2982,7 +3032,7 @@
                 <a:latin typeface="Consolas"/>
                 <a:ea typeface="Consolas"/>
               </a:rPr>
-              <a:t>&lt;queryFile&gt;../output/xmldb_queries/output_queries_20251017_140554.xml&lt;/queryFile&gt;</a:t>
+              <a:t>&lt;queryFile&gt;../output/xmldb_queries/queries-20260726-110822.xml&lt;/queryFile&gt;</a:t>
             </a:r>
           </a:p>
         </p:txBody>
@@ -3121,7 +3171,9 @@
           <a:noFill xmlns:a="http://schemas.openxmlformats.org/drawingml/2006/main"/>
         </p:spPr>
         <p:txBody>
-          <a:bodyPr xmlns:a="http://schemas.openxmlformats.org/drawingml/2006/main" wrap="square" anchor="t"/>
+          <a:bodyPr xmlns:a="http://schemas.openxmlformats.org/drawingml/2006/main" wrap="square" anchor="t">
+            <a:normAutofit/>
+          </a:bodyPr>
           <a:lstStyle xmlns:a="http://schemas.openxmlformats.org/drawingml/2006/main"/>
           <a:p xmlns:a="http://schemas.openxmlformats.org/drawingml/2006/main">
             <a:pPr algn="l">
@@ -3171,7 +3223,7 @@
         <p:txBody>
           <a:bodyPr xmlns:a="http://schemas.openxmlformats.org/drawingml/2006/main" wrap="square" lIns="146304" tIns="146304" rIns="146304" bIns="146304" anchor="t"/>
           <a:lstStyle xmlns:a="http://schemas.openxmlformats.org/drawingml/2006/main"/>
-          <a:p xmlns:a="http://schemas.openxmlformats.org/drawingml/2006/main">
+          <a:p>
             <a:pPr algn="l">
               <a:lnSpc>
                 <a:spcPct val="115000"/>
@@ -3181,7 +3233,7 @@
               </a:spcAft>
             </a:pPr>
             <a:r>
-              <a:rPr lang="en-US" sz="1300" b="0">
+              <a:rPr lang="en-US" sz="1200" b="0">
                 <a:solidFill>
                   <a:srgbClr val="1A1A1A"/>
                 </a:solidFill>
@@ -3191,7 +3243,7 @@
               <a:t>gcam-scratch/output/run_YYYYmmdd_HHMMSS/</a:t>
             </a:r>
           </a:p>
-          <a:p xmlns:a="http://schemas.openxmlformats.org/drawingml/2006/main">
+          <a:p>
             <a:pPr algn="l">
               <a:lnSpc>
                 <a:spcPct val="115000"/>
@@ -3201,7 +3253,7 @@
               </a:spcAft>
             </a:pPr>
             <a:r>
-              <a:rPr lang="en-US" sz="1300" b="0">
+              <a:rPr lang="en-US" sz="1200" b="0">
                 <a:solidFill>
                   <a:srgbClr val="1A1A1A"/>
                 </a:solidFill>
@@ -3211,7 +3263,7 @@
               <a:t>├─ output_&lt;task&gt;.txt        # 各任务标准输出</a:t>
             </a:r>
           </a:p>
-          <a:p xmlns:a="http://schemas.openxmlformats.org/drawingml/2006/main">
+          <a:p>
             <a:pPr algn="l">
               <a:lnSpc>
                 <a:spcPct val="115000"/>
@@ -3221,17 +3273,17 @@
               </a:spcAft>
             </a:pPr>
             <a:r>
-              <a:rPr lang="en-US" sz="1300" b="0">
+              <a:rPr lang="en-US" sz="1200" b="0">
                 <a:solidFill>
                   <a:srgbClr val="1A1A1A"/>
                 </a:solidFill>
                 <a:latin typeface="Consolas"/>
                 <a:ea typeface="Consolas"/>
               </a:rPr>
-              <a:t>├─ out_query_&lt;task&gt;/        # 各任务查询 CSV</a:t>
-            </a:r>
-          </a:p>
-          <a:p xmlns:a="http://schemas.openxmlformats.org/drawingml/2006/main">
+              <a:t>├─ out_query_&lt;task&gt;/        # 各任务 QUERY CSV</a:t>
+            </a:r>
+          </a:p>
+          <a:p>
             <a:pPr algn="l">
               <a:lnSpc>
                 <a:spcPct val="115000"/>
@@ -3241,14 +3293,14 @@
               </a:spcAft>
             </a:pPr>
             <a:r>
-              <a:rPr lang="en-US" sz="1300" b="0">
+              <a:rPr lang="en-US" sz="1200" b="0">
                 <a:solidFill>
                   <a:srgbClr val="1A1A1A"/>
                 </a:solidFill>
                 <a:latin typeface="Consolas"/>
                 <a:ea typeface="Consolas"/>
               </a:rPr>
-              <a:t>└─ Final_&lt;jobid&gt;.csv        # cat_queries.sh 合并的最终结果</a:t>
+              <a:t>└─ Final_&lt;merge-jobid&gt;.csv  # merge-query-results.sh 合并结果</a:t>
             </a:r>
           </a:p>
         </p:txBody>
@@ -3270,7 +3322,9 @@
           <a:noFill xmlns:a="http://schemas.openxmlformats.org/drawingml/2006/main"/>
         </p:spPr>
         <p:txBody>
-          <a:bodyPr xmlns:a="http://schemas.openxmlformats.org/drawingml/2006/main" wrap="square" anchor="t"/>
+          <a:bodyPr xmlns:a="http://schemas.openxmlformats.org/drawingml/2006/main" wrap="square" anchor="t">
+            <a:normAutofit/>
+          </a:bodyPr>
           <a:lstStyle xmlns:a="http://schemas.openxmlformats.org/drawingml/2006/main"/>
           <a:p xmlns:a="http://schemas.openxmlformats.org/drawingml/2006/main">
             <a:pPr algn="l">
@@ -3313,7 +3367,7 @@
         <p:txBody>
           <a:bodyPr xmlns:a="http://schemas.openxmlformats.org/drawingml/2006/main" wrap="square" anchor="t"/>
           <a:lstStyle xmlns:a="http://schemas.openxmlformats.org/drawingml/2006/main"/>
-          <a:p xmlns:a="http://schemas.openxmlformats.org/drawingml/2006/main">
+          <a:p>
             <a:pPr algn="l">
               <a:lnSpc>
                 <a:spcPct val="160000"/>
@@ -3330,10 +3384,10 @@
                 <a:latin typeface="Arial"/>
                 <a:ea typeface="微软雅黑"/>
               </a:rPr>
-              <a:t>• gcam_workspace.setup / master.sh 仍指向作者的 /lustre/... 绝对路径，未改为本机路径</a:t>
-            </a:r>
-          </a:p>
-          <a:p xmlns:a="http://schemas.openxmlformats.org/drawingml/2006/main">
+              <a:t>• 未解压 gcam-hpc-pku-libs.zip 内的 archive/libs.zip，导致 build-tools/libs/ 不完整</a:t>
+            </a:r>
+          </a:p>
+          <a:p>
             <a:pPr algn="l">
               <a:lnSpc>
                 <a:spcPct val="160000"/>
@@ -3350,10 +3404,10 @@
                 <a:latin typeface="Arial"/>
                 <a:ea typeface="微软雅黑"/>
               </a:rPr>
-              <a:t>• WM1 与 WM2 配置混用，导致分区、模块或依赖路径不匹配</a:t>
-            </a:r>
-          </a:p>
-          <a:p xmlns:a="http://schemas.openxmlformats.org/drawingml/2006/main">
+              <a:t>• 工作区存在多个 gcam-* 源码目录，或 GCAMDIR 指向错误</a:t>
+            </a:r>
+          </a:p>
+          <a:p>
             <a:pPr algn="l">
               <a:lnSpc>
                 <a:spcPct val="160000"/>
@@ -3370,10 +3424,10 @@
                 <a:latin typeface="Arial"/>
                 <a:ea typeface="微软雅黑"/>
               </a:rPr>
-              <a:t>• 子模块未拉取，缺少 hector 或 modelinterface</a:t>
-            </a:r>
-          </a:p>
-          <a:p xmlns:a="http://schemas.openxmlformats.org/drawingml/2006/main">
+              <a:t>• cluster profile 选择错误，Slurm partition、module 或依赖路径不匹配</a:t>
+            </a:r>
+          </a:p>
+          <a:p>
             <a:pPr algn="l">
               <a:lnSpc>
                 <a:spcPct val="160000"/>
@@ -3390,10 +3444,10 @@
                 <a:latin typeface="Arial"/>
                 <a:ea typeface="微软雅黑"/>
               </a:rPr>
-              <a:t>• build-tools 中 jars、eigen、java_linux、tbb-linux、boost-lib 路径与 setup 文件不一致</a:t>
-            </a:r>
-          </a:p>
-          <a:p xmlns:a="http://schemas.openxmlformats.org/drawingml/2006/main">
+              <a:t>• RUN 前未生成 queries-*.xml，或 modelinterface-batch.xml 仍指向旧文件名</a:t>
+            </a:r>
+          </a:p>
+          <a:p>
             <a:pPr algn="l">
               <a:lnSpc>
                 <a:spcPct val="160000"/>
@@ -3410,7 +3464,7 @@
                 <a:latin typeface="Arial"/>
                 <a:ea typeface="微软雅黑"/>
               </a:rPr>
-              <a:t>• RUN 前未生成查询 XML，或 xmldb_batch.xml 仍指向旧文件名；这会使每个情景的 QUERY 失败</a:t>
+              <a:t>• QUERY 的 region / query 名称与定义文件不一致</a:t>
             </a:r>
           </a:p>
         </p:txBody>
@@ -3758,7 +3812,7 @@
                 <a:latin typeface="Arial"/>
                 <a:ea typeface="微软雅黑"/>
               </a:rPr>
-              <a:t>BUILD   source build setup → make gcam → gcam.exe</a:t>
+              <a:t>BUILD   上传源码 → 解压 libs → source environment.sh → make gcam</a:t>
             </a:r>
           </a:p>
           <a:p>
@@ -3778,7 +3832,7 @@
                 <a:latin typeface="Arial"/>
                 <a:ea typeface="微软雅黑"/>
               </a:rPr>
-              <a:t>RUN     前置检查 QUERY → master.sh → 每个情景运行 GCAM + QUERY</a:t>
+              <a:t>QUERY   选择 regions / queries → build_queries.py → 配置 modelinterface-batch.xml</a:t>
             </a:r>
           </a:p>
           <a:p>
@@ -3798,7 +3852,7 @@
                 <a:latin typeface="Arial"/>
                 <a:ea typeface="微软雅黑"/>
               </a:rPr>
-              <a:t>QUERY   预先配置；运行后自动合并所有情景为 Final_&lt;jobid&gt;.csv</a:t>
+              <a:t>RUN     run-pipeline.sh → 每个情景运行 GCAM + QUERY → 自动合并 CSV</a:t>
             </a:r>
           </a:p>
         </p:txBody>
@@ -5873,8 +5927,8 @@
         </p:nvSpPr>
         <p:spPr>
           <a:xfrm>
-            <a:off x="397951" y="5641619"/>
-            <a:ext cx="4491018" cy="369332"/>
+            <a:off x="397951" y="6480000"/>
+            <a:ext cx="4491018" cy="216000"/>
           </a:xfrm>
           <a:prstGeom prst="rect">
             <a:avLst/>
@@ -5957,7 +6011,7 @@
       </p:sp>
       <p:pic>
         <p:nvPicPr>
-          <p:cNvPr id="16" name="Picture 15">
+          <p:cNvPr id="16" name="Picture 15" descr="GCAM-HPC parallel scenario execution">
             <a:extLst>
               <a:ext uri="{FF2B5EF4-FFF2-40B4-BE49-F238E27FC236}">
                 <a16:creationId xmlns:a16="http://schemas.microsoft.com/office/drawing/2014/main" id="{8BE74F7F-3B17-95FC-AE71-A25874477E8B}"/>
@@ -5970,560 +6024,21 @@
           <p:nvPr/>
         </p:nvPicPr>
         <p:blipFill>
-          <a:blip r:embed="rId5"/>
+          <a:blip r:embed="Rd734edb2bef542c9"/>
           <a:stretch>
             <a:fillRect/>
           </a:stretch>
         </p:blipFill>
         <p:spPr>
           <a:xfrm>
-            <a:off x="293164" y="1031715"/>
-            <a:ext cx="5852900" cy="4325194"/>
+            <a:off x="1584000" y="792000"/>
+            <a:ext cx="9000000" cy="5569200"/>
           </a:xfrm>
           <a:prstGeom prst="rect">
             <a:avLst/>
           </a:prstGeom>
         </p:spPr>
       </p:pic>
-      <p:sp>
-        <p:nvSpPr>
-          <p:cNvPr id="19" name="TextBox 18">
-            <a:extLst>
-              <a:ext uri="{FF2B5EF4-FFF2-40B4-BE49-F238E27FC236}">
-                <a16:creationId xmlns:a16="http://schemas.microsoft.com/office/drawing/2014/main" id="{6303A23C-4AC2-2026-A43C-B0957B13CC54}"/>
-              </a:ext>
-            </a:extLst>
-          </p:cNvPr>
-          <p:cNvSpPr txBox="1"/>
-          <p:nvPr/>
-        </p:nvSpPr>
-        <p:spPr>
-          <a:xfrm>
-            <a:off x="6409320" y="1629395"/>
-            <a:ext cx="5782680" cy="677108"/>
-          </a:xfrm>
-          <a:prstGeom prst="rect">
-            <a:avLst/>
-          </a:prstGeom>
-          <a:noFill/>
-        </p:spPr>
-        <p:txBody>
-          <a:bodyPr wrap="square">
-            <a:spAutoFit/>
-          </a:bodyPr>
-          <a:lstStyle/>
-          <a:p>
-            <a:pPr marL="0" marR="0" lvl="0" indent="0" algn="l" defTabSz="914400" rtl="0" eaLnBrk="1" fontAlgn="auto" latinLnBrk="0" hangingPunct="1">
-              <a:lnSpc>
-                <a:spcPct val="100000"/>
-              </a:lnSpc>
-              <a:spcBef>
-                <a:spcPts val="0"/>
-              </a:spcBef>
-              <a:spcAft>
-                <a:spcPts val="0"/>
-              </a:spcAft>
-              <a:buClrTx/>
-              <a:buSzTx/>
-              <a:buFontTx/>
-              <a:buNone/>
-              <a:tabLst/>
-              <a:defRPr/>
-            </a:pPr>
-            <a:r>
-              <a:rPr kumimoji="0" lang="zh-CN" altLang="en-US" sz="2000" b="1" i="0" u="none" strike="noStrike" kern="1200" cap="none" spc="0" normalizeH="0" baseline="0" noProof="1">
-                <a:ln>
-                  <a:noFill/>
-                </a:ln>
-                <a:solidFill>
-                  <a:prstClr val="black"/>
-                </a:solidFill>
-                <a:effectLst/>
-                <a:uLnTx/>
-                <a:uFillTx/>
-                <a:latin typeface="微软雅黑"/>
-                <a:ea typeface="微软雅黑"/>
-                <a:cs typeface="+mn-cs"/>
-              </a:rPr>
-              <a:t>多情景并行，实现</a:t>
-            </a:r>
-            <a:r>
-              <a:rPr kumimoji="0" lang="zh-CN" altLang="en-US" sz="2000" b="1" i="0" u="none" strike="noStrike" kern="1200" cap="none" spc="0" normalizeH="0" baseline="0" noProof="1">
-                <a:ln>
-                  <a:noFill/>
-                </a:ln>
-                <a:solidFill>
-                  <a:srgbClr val="004AB8"/>
-                </a:solidFill>
-                <a:effectLst/>
-                <a:uLnTx/>
-                <a:uFillTx/>
-                <a:latin typeface="微软雅黑"/>
-                <a:ea typeface="微软雅黑"/>
-                <a:cs typeface="+mn-cs"/>
-              </a:rPr>
-              <a:t>规模化测试及情景阵列构建</a:t>
-            </a:r>
-            <a:endParaRPr kumimoji="0" lang="en-GB" altLang="zh-CN" sz="2000" b="1" i="0" u="none" strike="noStrike" kern="1200" cap="none" spc="0" normalizeH="0" baseline="0" noProof="1">
-              <a:ln>
-                <a:noFill/>
-              </a:ln>
-              <a:solidFill>
-                <a:srgbClr val="004AB8"/>
-              </a:solidFill>
-              <a:effectLst/>
-              <a:uLnTx/>
-              <a:uFillTx/>
-              <a:latin typeface="微软雅黑"/>
-              <a:ea typeface="微软雅黑"/>
-              <a:cs typeface="+mn-cs"/>
-            </a:endParaRPr>
-          </a:p>
-          <a:p>
-            <a:pPr marL="0" marR="0" lvl="0" indent="0" algn="l" defTabSz="914400" rtl="0" eaLnBrk="1" fontAlgn="auto" latinLnBrk="0" hangingPunct="1">
-              <a:lnSpc>
-                <a:spcPct val="100000"/>
-              </a:lnSpc>
-              <a:spcBef>
-                <a:spcPts val="0"/>
-              </a:spcBef>
-              <a:spcAft>
-                <a:spcPts val="0"/>
-              </a:spcAft>
-              <a:buClrTx/>
-              <a:buSzTx/>
-              <a:buFontTx/>
-              <a:buNone/>
-              <a:tabLst/>
-              <a:defRPr/>
-            </a:pPr>
-            <a:r>
-              <a:rPr kumimoji="0" lang="zh-CN" altLang="en-US" sz="1800" b="0" i="0" u="none" strike="noStrike" kern="1200" cap="none" spc="0" normalizeH="0" baseline="0" noProof="1">
-                <a:ln>
-                  <a:noFill/>
-                </a:ln>
-                <a:solidFill>
-                  <a:prstClr val="black"/>
-                </a:solidFill>
-                <a:effectLst/>
-                <a:uLnTx/>
-                <a:uFillTx/>
-                <a:latin typeface="微软雅黑"/>
-                <a:ea typeface="微软雅黑"/>
-                <a:cs typeface="+mn-cs"/>
-              </a:rPr>
-              <a:t>（适配任意版本</a:t>
-            </a:r>
-            <a:r>
-              <a:rPr kumimoji="0" lang="en-US" altLang="zh-CN" sz="1800" b="0" i="0" u="none" strike="noStrike" kern="1200" cap="none" spc="0" normalizeH="0" baseline="0" noProof="1">
-                <a:ln>
-                  <a:noFill/>
-                </a:ln>
-                <a:solidFill>
-                  <a:prstClr val="black"/>
-                </a:solidFill>
-                <a:effectLst/>
-                <a:uLnTx/>
-                <a:uFillTx/>
-                <a:latin typeface="微软雅黑"/>
-                <a:ea typeface="微软雅黑"/>
-                <a:cs typeface="+mn-cs"/>
-              </a:rPr>
-              <a:t>GCAM-core/GCAM-China</a:t>
-            </a:r>
-            <a:r>
-              <a:rPr kumimoji="0" lang="zh-CN" altLang="en-US" sz="1800" b="0" i="0" u="none" strike="noStrike" kern="1200" cap="none" spc="0" normalizeH="0" baseline="0" noProof="1">
-                <a:ln>
-                  <a:noFill/>
-                </a:ln>
-                <a:solidFill>
-                  <a:prstClr val="black"/>
-                </a:solidFill>
-                <a:effectLst/>
-                <a:uLnTx/>
-                <a:uFillTx/>
-                <a:latin typeface="微软雅黑"/>
-                <a:ea typeface="微软雅黑"/>
-                <a:cs typeface="+mn-cs"/>
-              </a:rPr>
-              <a:t>）</a:t>
-            </a:r>
-          </a:p>
-        </p:txBody>
-      </p:sp>
-      <p:pic>
-        <p:nvPicPr>
-          <p:cNvPr id="20" name="Picture 19">
-            <a:extLst>
-              <a:ext uri="{FF2B5EF4-FFF2-40B4-BE49-F238E27FC236}">
-                <a16:creationId xmlns:a16="http://schemas.microsoft.com/office/drawing/2014/main" id="{295F7BDC-99AB-5242-9AE2-10E8BCC501FC}"/>
-              </a:ext>
-            </a:extLst>
-          </p:cNvPr>
-          <p:cNvPicPr>
-            <a:picLocks noChangeAspect="1"/>
-          </p:cNvPicPr>
-          <p:nvPr/>
-        </p:nvPicPr>
-        <p:blipFill>
-          <a:blip r:embed="rId6"/>
-          <a:srcRect r="3073"/>
-          <a:stretch>
-            <a:fillRect/>
-          </a:stretch>
-        </p:blipFill>
-        <p:spPr>
-          <a:xfrm>
-            <a:off x="6360488" y="2306503"/>
-            <a:ext cx="5627873" cy="2932657"/>
-          </a:xfrm>
-          <a:prstGeom prst="rect">
-            <a:avLst/>
-          </a:prstGeom>
-        </p:spPr>
-      </p:pic>
-      <p:pic>
-        <p:nvPicPr>
-          <p:cNvPr id="25" name="Picture 2" descr="Csv - Free interface icons">
-            <a:extLst>
-              <a:ext uri="{FF2B5EF4-FFF2-40B4-BE49-F238E27FC236}">
-                <a16:creationId xmlns:a16="http://schemas.microsoft.com/office/drawing/2014/main" id="{34FA252B-6FE9-691D-FDD5-1186D0C0DB27}"/>
-              </a:ext>
-            </a:extLst>
-          </p:cNvPr>
-          <p:cNvPicPr>
-            <a:picLocks noChangeAspect="1" noChangeArrowheads="1"/>
-          </p:cNvPicPr>
-          <p:nvPr/>
-        </p:nvPicPr>
-        <p:blipFill>
-          <a:blip r:embed="rId7">
-            <a:extLst>
-              <a:ext uri="{28A0092B-C50C-407E-A947-70E740481C1C}">
-                <a14:useLocalDpi xmlns:a14="http://schemas.microsoft.com/office/drawing/2010/main" val="0"/>
-              </a:ext>
-            </a:extLst>
-          </a:blip>
-          <a:srcRect/>
-          <a:stretch>
-            <a:fillRect/>
-          </a:stretch>
-        </p:blipFill>
-        <p:spPr bwMode="auto">
-          <a:xfrm>
-            <a:off x="10236231" y="5515905"/>
-            <a:ext cx="837823" cy="837823"/>
-          </a:xfrm>
-          <a:prstGeom prst="rect">
-            <a:avLst/>
-          </a:prstGeom>
-          <a:noFill/>
-          <a:extLst>
-            <a:ext uri="{909E8E84-426E-40DD-AFC4-6F175D3DCCD1}">
-              <a14:hiddenFill xmlns:a14="http://schemas.microsoft.com/office/drawing/2010/main">
-                <a:solidFill>
-                  <a:srgbClr val="FFFFFF"/>
-                </a:solidFill>
-              </a14:hiddenFill>
-            </a:ext>
-          </a:extLst>
-        </p:spPr>
-      </p:pic>
-      <p:sp>
-        <p:nvSpPr>
-          <p:cNvPr id="26" name="箭头: 右 11">
-            <a:extLst>
-              <a:ext uri="{FF2B5EF4-FFF2-40B4-BE49-F238E27FC236}">
-                <a16:creationId xmlns:a16="http://schemas.microsoft.com/office/drawing/2014/main" id="{2D489C00-4818-3049-4C30-68DE67E5122C}"/>
-              </a:ext>
-            </a:extLst>
-          </p:cNvPr>
-          <p:cNvSpPr/>
-          <p:nvPr/>
-        </p:nvSpPr>
-        <p:spPr>
-          <a:xfrm rot="5400000">
-            <a:off x="9506193" y="5399562"/>
-            <a:ext cx="904602" cy="402510"/>
-          </a:xfrm>
-          <a:prstGeom prst="rightArrow">
-            <a:avLst/>
-          </a:prstGeom>
-          <a:solidFill>
-            <a:srgbClr val="004AB8"/>
-          </a:solidFill>
-          <a:ln>
-            <a:noFill/>
-          </a:ln>
-        </p:spPr>
-        <p:style>
-          <a:lnRef idx="2">
-            <a:schemeClr val="accent1">
-              <a:shade val="50000"/>
-            </a:schemeClr>
-          </a:lnRef>
-          <a:fillRef idx="1">
-            <a:schemeClr val="accent1"/>
-          </a:fillRef>
-          <a:effectRef idx="0">
-            <a:schemeClr val="accent1"/>
-          </a:effectRef>
-          <a:fontRef idx="minor">
-            <a:schemeClr val="lt1"/>
-          </a:fontRef>
-        </p:style>
-        <p:txBody>
-          <a:bodyPr rtlCol="0" anchor="ctr"/>
-          <a:lstStyle/>
-          <a:p>
-            <a:pPr marL="0" marR="0" lvl="0" indent="0" algn="ctr" defTabSz="914400" rtl="0" eaLnBrk="1" fontAlgn="auto" latinLnBrk="0" hangingPunct="1">
-              <a:lnSpc>
-                <a:spcPct val="100000"/>
-              </a:lnSpc>
-              <a:spcBef>
-                <a:spcPts val="0"/>
-              </a:spcBef>
-              <a:spcAft>
-                <a:spcPts val="0"/>
-              </a:spcAft>
-              <a:buClrTx/>
-              <a:buSzTx/>
-              <a:buFontTx/>
-              <a:buNone/>
-              <a:tabLst/>
-              <a:defRPr/>
-            </a:pPr>
-            <a:endParaRPr kumimoji="0" lang="zh-CN" altLang="en-US" sz="1800" b="0" i="0" u="none" strike="noStrike" kern="1200" cap="none" spc="0" normalizeH="0" baseline="0" noProof="0">
-              <a:ln>
-                <a:noFill/>
-              </a:ln>
-              <a:solidFill>
-                <a:prstClr val="white"/>
-              </a:solidFill>
-              <a:effectLst/>
-              <a:uLnTx/>
-              <a:uFillTx/>
-              <a:latin typeface="Arial"/>
-              <a:ea typeface="微软雅黑"/>
-              <a:cs typeface="+mn-cs"/>
-            </a:endParaRPr>
-          </a:p>
-        </p:txBody>
-      </p:sp>
-      <p:sp>
-        <p:nvSpPr>
-          <p:cNvPr id="28" name="TextBox 27">
-            <a:extLst>
-              <a:ext uri="{FF2B5EF4-FFF2-40B4-BE49-F238E27FC236}">
-                <a16:creationId xmlns:a16="http://schemas.microsoft.com/office/drawing/2014/main" id="{592A58F9-1F84-A805-0279-27842FE2A32A}"/>
-              </a:ext>
-            </a:extLst>
-          </p:cNvPr>
-          <p:cNvSpPr txBox="1"/>
-          <p:nvPr/>
-        </p:nvSpPr>
-        <p:spPr>
-          <a:xfrm>
-            <a:off x="6498331" y="5356909"/>
-            <a:ext cx="4968083" cy="874920"/>
-          </a:xfrm>
-          <a:prstGeom prst="rect">
-            <a:avLst/>
-          </a:prstGeom>
-          <a:noFill/>
-        </p:spPr>
-        <p:txBody>
-          <a:bodyPr wrap="square">
-            <a:spAutoFit/>
-          </a:bodyPr>
-          <a:lstStyle/>
-          <a:p>
-            <a:pPr marL="0" marR="0" lvl="0" indent="0" algn="l" defTabSz="914400" rtl="0" eaLnBrk="1" fontAlgn="auto" latinLnBrk="0" hangingPunct="1">
-              <a:lnSpc>
-                <a:spcPct val="150000"/>
-              </a:lnSpc>
-              <a:spcBef>
-                <a:spcPts val="0"/>
-              </a:spcBef>
-              <a:spcAft>
-                <a:spcPts val="0"/>
-              </a:spcAft>
-              <a:buClrTx/>
-              <a:buSzTx/>
-              <a:buFontTx/>
-              <a:buNone/>
-              <a:tabLst/>
-              <a:defRPr/>
-            </a:pPr>
-            <a:r>
-              <a:rPr kumimoji="0" lang="zh-CN" altLang="en-US" sz="1800" b="0" i="0" u="none" strike="noStrike" kern="1200" cap="none" spc="0" normalizeH="0" baseline="0" noProof="1">
-                <a:ln>
-                  <a:noFill/>
-                </a:ln>
-                <a:solidFill>
-                  <a:prstClr val="black"/>
-                </a:solidFill>
-                <a:effectLst/>
-                <a:uLnTx/>
-                <a:uFillTx/>
-                <a:latin typeface="Microsoft YaHei UI" panose="020B0503020204020204" pitchFamily="34" charset="-122"/>
-                <a:ea typeface="Microsoft YaHei UI" panose="020B0503020204020204" pitchFamily="34" charset="-122"/>
-                <a:cs typeface="+mn-cs"/>
-              </a:rPr>
-              <a:t>服务器端</a:t>
-            </a:r>
-            <a:r>
-              <a:rPr kumimoji="0" lang="zh-CN" altLang="en-US" sz="1800" b="1" i="0" u="none" strike="noStrike" kern="1200" cap="none" spc="0" normalizeH="0" baseline="0" noProof="1">
-                <a:ln>
-                  <a:noFill/>
-                </a:ln>
-                <a:solidFill>
-                  <a:prstClr val="black"/>
-                </a:solidFill>
-                <a:effectLst/>
-                <a:uLnTx/>
-                <a:uFillTx/>
-                <a:latin typeface="Microsoft YaHei UI" panose="020B0503020204020204" pitchFamily="34" charset="-122"/>
-                <a:ea typeface="Microsoft YaHei UI" panose="020B0503020204020204" pitchFamily="34" charset="-122"/>
-                <a:cs typeface="+mn-cs"/>
-              </a:rPr>
-              <a:t>定制处理</a:t>
-            </a:r>
-            <a:r>
-              <a:rPr kumimoji="0" lang="zh-CN" altLang="en-US" sz="1800" b="0" i="0" u="none" strike="noStrike" kern="1200" cap="none" spc="0" normalizeH="0" baseline="0" noProof="1">
-                <a:ln>
-                  <a:noFill/>
-                </a:ln>
-                <a:solidFill>
-                  <a:prstClr val="black"/>
-                </a:solidFill>
-                <a:effectLst/>
-                <a:uLnTx/>
-                <a:uFillTx/>
-                <a:latin typeface="Microsoft YaHei UI" panose="020B0503020204020204" pitchFamily="34" charset="-122"/>
-                <a:ea typeface="Microsoft YaHei UI" panose="020B0503020204020204" pitchFamily="34" charset="-122"/>
-                <a:cs typeface="+mn-cs"/>
-              </a:rPr>
-              <a:t>模型结果</a:t>
-            </a:r>
-            <a:endParaRPr kumimoji="0" lang="en-GB" altLang="zh-CN" sz="1800" b="0" i="0" u="none" strike="noStrike" kern="1200" cap="none" spc="0" normalizeH="0" baseline="0" noProof="1">
-              <a:ln>
-                <a:noFill/>
-              </a:ln>
-              <a:solidFill>
-                <a:prstClr val="black"/>
-              </a:solidFill>
-              <a:effectLst/>
-              <a:uLnTx/>
-              <a:uFillTx/>
-              <a:latin typeface="Microsoft YaHei UI" panose="020B0503020204020204" pitchFamily="34" charset="-122"/>
-              <a:ea typeface="Microsoft YaHei UI" panose="020B0503020204020204" pitchFamily="34" charset="-122"/>
-              <a:cs typeface="+mn-cs"/>
-            </a:endParaRPr>
-          </a:p>
-          <a:p>
-            <a:pPr marL="0" marR="0" lvl="0" indent="0" algn="l" defTabSz="914400" rtl="0" eaLnBrk="1" fontAlgn="auto" latinLnBrk="0" hangingPunct="1">
-              <a:lnSpc>
-                <a:spcPct val="150000"/>
-              </a:lnSpc>
-              <a:spcBef>
-                <a:spcPts val="0"/>
-              </a:spcBef>
-              <a:spcAft>
-                <a:spcPts val="0"/>
-              </a:spcAft>
-              <a:buClrTx/>
-              <a:buSzTx/>
-              <a:buFontTx/>
-              <a:buNone/>
-              <a:tabLst/>
-              <a:defRPr/>
-            </a:pPr>
-            <a:r>
-              <a:rPr kumimoji="0" lang="zh-CN" altLang="en-US" sz="1800" b="0" i="0" u="none" strike="noStrike" kern="1200" cap="none" spc="0" normalizeH="0" baseline="0" noProof="1">
-                <a:ln>
-                  <a:noFill/>
-                </a:ln>
-                <a:solidFill>
-                  <a:prstClr val="black"/>
-                </a:solidFill>
-                <a:effectLst/>
-                <a:uLnTx/>
-                <a:uFillTx/>
-                <a:latin typeface="Microsoft YaHei UI" panose="020B0503020204020204" pitchFamily="34" charset="-122"/>
-                <a:ea typeface="Microsoft YaHei UI" panose="020B0503020204020204" pitchFamily="34" charset="-122"/>
-                <a:cs typeface="+mn-cs"/>
-              </a:rPr>
-              <a:t>合并为</a:t>
-            </a:r>
-            <a:r>
-              <a:rPr kumimoji="0" lang="zh-CN" altLang="en-US" sz="1800" b="1" i="0" u="none" strike="noStrike" kern="1200" cap="none" spc="0" normalizeH="0" baseline="0" noProof="1">
-                <a:ln>
-                  <a:noFill/>
-                </a:ln>
-                <a:solidFill>
-                  <a:prstClr val="black"/>
-                </a:solidFill>
-                <a:effectLst/>
-                <a:uLnTx/>
-                <a:uFillTx/>
-                <a:latin typeface="Microsoft YaHei UI" panose="020B0503020204020204" pitchFamily="34" charset="-122"/>
-                <a:ea typeface="Microsoft YaHei UI" panose="020B0503020204020204" pitchFamily="34" charset="-122"/>
-                <a:cs typeface="+mn-cs"/>
-              </a:rPr>
-              <a:t>轻量级</a:t>
-            </a:r>
-            <a:r>
-              <a:rPr kumimoji="0" lang="en-US" altLang="zh-CN" sz="1800" b="1" i="0" u="none" strike="noStrike" kern="1200" cap="none" spc="0" normalizeH="0" baseline="0" noProof="1">
-                <a:ln>
-                  <a:noFill/>
-                </a:ln>
-                <a:solidFill>
-                  <a:prstClr val="black"/>
-                </a:solidFill>
-                <a:effectLst/>
-                <a:uLnTx/>
-                <a:uFillTx/>
-                <a:latin typeface="Microsoft YaHei UI" panose="020B0503020204020204" pitchFamily="34" charset="-122"/>
-                <a:ea typeface="Microsoft YaHei UI" panose="020B0503020204020204" pitchFamily="34" charset="-122"/>
-                <a:cs typeface="+mn-cs"/>
-              </a:rPr>
-              <a:t>csv</a:t>
-            </a:r>
-            <a:r>
-              <a:rPr kumimoji="0" lang="zh-CN" altLang="en-US" sz="1800" b="1" i="0" u="none" strike="noStrike" kern="1200" cap="none" spc="0" normalizeH="0" baseline="0" noProof="1">
-                <a:ln>
-                  <a:noFill/>
-                </a:ln>
-                <a:solidFill>
-                  <a:prstClr val="black"/>
-                </a:solidFill>
-                <a:effectLst/>
-                <a:uLnTx/>
-                <a:uFillTx/>
-                <a:latin typeface="Microsoft YaHei UI" panose="020B0503020204020204" pitchFamily="34" charset="-122"/>
-                <a:ea typeface="Microsoft YaHei UI" panose="020B0503020204020204" pitchFamily="34" charset="-122"/>
-                <a:cs typeface="+mn-cs"/>
-              </a:rPr>
-              <a:t>格式</a:t>
-            </a:r>
-            <a:endParaRPr kumimoji="0" lang="en-GB" altLang="zh-CN" sz="1800" b="1" i="0" u="none" strike="noStrike" kern="1200" cap="none" spc="0" normalizeH="0" baseline="0" noProof="1">
-              <a:ln>
-                <a:noFill/>
-              </a:ln>
-              <a:solidFill>
-                <a:prstClr val="black"/>
-              </a:solidFill>
-              <a:effectLst/>
-              <a:uLnTx/>
-              <a:uFillTx/>
-              <a:latin typeface="Microsoft YaHei UI" panose="020B0503020204020204" pitchFamily="34" charset="-122"/>
-              <a:ea typeface="Microsoft YaHei UI" panose="020B0503020204020204" pitchFamily="34" charset="-122"/>
-              <a:cs typeface="+mn-cs"/>
-            </a:endParaRPr>
-          </a:p>
-        </p:txBody>
-      </p:sp>
       <p:sp>
         <p:nvSpPr>
           <p:cNvPr id="30" name="Slide Number Placeholder 3">
@@ -7055,7 +6570,7 @@
         <p:txBody>
           <a:bodyPr xmlns:a="http://schemas.openxmlformats.org/drawingml/2006/main" wrap="square" anchor="t"/>
           <a:lstStyle xmlns:a="http://schemas.openxmlformats.org/drawingml/2006/main"/>
-          <a:p xmlns:a="http://schemas.openxmlformats.org/drawingml/2006/main">
+          <a:p>
             <a:pPr algn="l">
               <a:lnSpc>
                 <a:spcPct val="125000"/>
@@ -7072,10 +6587,10 @@
                 <a:latin typeface="Arial"/>
                 <a:ea typeface="微软雅黑"/>
               </a:rPr>
-              <a:t>拉取 GCAM 源码，配置依赖库与环境变量，编译生成 gcam.exe。</a:t>
-            </a:r>
-          </a:p>
-          <a:p xmlns:a="http://schemas.openxmlformats.org/drawingml/2006/main">
+              <a:t>本地下载并上传 GCAM 源码，解压 HPC 依赖，统一加载 environment.sh 后编译。</a:t>
+            </a:r>
+          </a:p>
+          <a:p>
             <a:pPr algn="l">
               <a:lnSpc>
                 <a:spcPct val="125000"/>
@@ -7095,7 +6610,7 @@
               <a:t/>
             </a:r>
           </a:p>
-          <a:p xmlns:a="http://schemas.openxmlformats.org/drawingml/2006/main">
+          <a:p>
             <a:pPr algn="l">
               <a:lnSpc>
                 <a:spcPct val="125000"/>
@@ -7112,7 +6627,7 @@
                 <a:latin typeface="Arial"/>
                 <a:ea typeface="微软雅黑"/>
               </a:rPr>
-              <a:t>同一套工具适配任意 gcam-core / gcam-china 版本，自动识别源码目录。</a:t>
+              <a:t>适配 gcam-core / gcam-china，自动识别源码目录。</a:t>
             </a:r>
           </a:p>
         </p:txBody>
@@ -7225,7 +6740,7 @@
                 <a:latin typeface="Arial"/>
                 <a:ea typeface="微软雅黑"/>
               </a:rPr>
-              <a:t>master.sh 同步预配置 QUERY、生成情景并提交作业；每个情景运行后立即执行同一组查询。</a:t>
+              <a:t>run-pipeline.sh 同步输入与预配置 QUERY，生成情景和 Slurm 作业；每个情景运行后执行同一组查询。</a:t>
             </a:r>
           </a:p>
         </p:txBody>
@@ -7360,7 +6875,9 @@
           <a:noFill xmlns:a="http://schemas.openxmlformats.org/drawingml/2006/main"/>
         </p:spPr>
         <p:txBody>
-          <a:bodyPr xmlns:a="http://schemas.openxmlformats.org/drawingml/2006/main" wrap="square" anchor="t"/>
+          <a:bodyPr xmlns:a="http://schemas.openxmlformats.org/drawingml/2006/main" wrap="square" anchor="t">
+            <a:normAutofit/>
+          </a:bodyPr>
           <a:lstStyle xmlns:a="http://schemas.openxmlformats.org/drawingml/2006/main"/>
           <a:p xmlns:a="http://schemas.openxmlformats.org/drawingml/2006/main">
             <a:pPr algn="l">
@@ -7379,7 +6896,7 @@
                 <a:latin typeface="Arial"/>
                 <a:ea typeface="微软雅黑"/>
               </a:rPr>
-              <a:t>两个关键环境变量</a:t>
+              <a:t>统一环境变量</a:t>
             </a:r>
           </a:p>
         </p:txBody>
@@ -7408,9 +6925,11 @@
           </a:ln>
         </p:spPr>
         <p:txBody>
-          <a:bodyPr xmlns:a="http://schemas.openxmlformats.org/drawingml/2006/main" wrap="square" lIns="146304" tIns="146304" rIns="146304" bIns="146304" anchor="t"/>
-          <a:lstStyle xmlns:a="http://schemas.openxmlformats.org/drawingml/2006/main"/>
-          <a:p xmlns:a="http://schemas.openxmlformats.org/drawingml/2006/main">
+          <a:bodyPr xmlns:a="http://schemas.openxmlformats.org/drawingml/2006/main" wrap="square" lIns="146304" tIns="146304" rIns="146304" bIns="146304" anchor="t">
+            <a:normAutofit/>
+          </a:bodyPr>
+          <a:lstStyle xmlns:a="http://schemas.openxmlformats.org/drawingml/2006/main"/>
+          <a:p>
             <a:pPr algn="l">
               <a:lnSpc>
                 <a:spcPct val="115000"/>
@@ -7427,10 +6946,10 @@
                 <a:latin typeface="Consolas"/>
                 <a:ea typeface="Consolas"/>
               </a:rPr>
-              <a:t>GCAM_WORKSPACE       # 编译期使用，指向仓库根目录</a:t>
-            </a:r>
-          </a:p>
-          <a:p xmlns:a="http://schemas.openxmlformats.org/drawingml/2006/main">
+              <a:t>GCAM_HPC_WORKSPACE   # 仓库根目录</a:t>
+            </a:r>
+          </a:p>
+          <a:p>
             <a:pPr algn="l">
               <a:lnSpc>
                 <a:spcPct val="115000"/>
@@ -7447,7 +6966,7 @@
                 <a:latin typeface="Consolas"/>
                 <a:ea typeface="Consolas"/>
               </a:rPr>
-              <a:t>GCAM_HPC_WORKSPACE   # 运行期使用，指向同一仓库根目录</a:t>
+              <a:t>GCAM_HPC_CLUSTER     # wm1 / wm2 / 自定义 profile</a:t>
             </a:r>
           </a:p>
         </p:txBody>
@@ -7636,7 +7155,7 @@
         <p:txBody>
           <a:bodyPr xmlns:a="http://schemas.openxmlformats.org/drawingml/2006/main" wrap="square" lIns="146304" tIns="146304" rIns="146304" bIns="146304" anchor="t"/>
           <a:lstStyle xmlns:a="http://schemas.openxmlformats.org/drawingml/2006/main"/>
-          <a:p xmlns:a="http://schemas.openxmlformats.org/drawingml/2006/main">
+          <a:p>
             <a:pPr algn="l">
               <a:lnSpc>
                 <a:spcPct val="115000"/>
@@ -7656,7 +7175,7 @@
               <a:t>gcam-hpc-PKU/</a:t>
             </a:r>
           </a:p>
-          <a:p xmlns:a="http://schemas.openxmlformats.org/drawingml/2006/main">
+          <a:p>
             <a:pPr algn="l">
               <a:lnSpc>
                 <a:spcPct val="115000"/>
@@ -7673,10 +7192,10 @@
                 <a:latin typeface="Consolas"/>
                 <a:ea typeface="Consolas"/>
               </a:rPr>
-              <a:t>├─ gcam-core/                     GCAM 核心源码与编译产物 (exe/gcam.exe)</a:t>
-            </a:r>
-          </a:p>
-          <a:p xmlns:a="http://schemas.openxmlformats.org/drawingml/2006/main">
+              <a:t>├─ gcam-core/ 或 gcam-china-*/       GCAM 源码与编译产物</a:t>
+            </a:r>
+          </a:p>
+          <a:p>
             <a:pPr algn="l">
               <a:lnSpc>
                 <a:spcPct val="115000"/>
@@ -7696,7 +7215,7 @@
               <a:t>├─ gcam-hpc-tools/</a:t>
             </a:r>
           </a:p>
-          <a:p xmlns:a="http://schemas.openxmlformats.org/drawingml/2006/main">
+          <a:p>
             <a:pPr algn="l">
               <a:lnSpc>
                 <a:spcPct val="115000"/>
@@ -7713,10 +7232,10 @@
                 <a:latin typeface="Consolas"/>
                 <a:ea typeface="Consolas"/>
               </a:rPr>
-              <a:t>│   ├─ gcam_workspace.setup       运行期环境变量入口（导出所有路径）</a:t>
-            </a:r>
-          </a:p>
-          <a:p xmlns:a="http://schemas.openxmlformats.org/drawingml/2006/main">
+              <a:t>│   ├─ build-tools/                  environment.sh · 依赖包 · profiles</a:t>
+            </a:r>
+          </a:p>
+          <a:p>
             <a:pPr algn="l">
               <a:lnSpc>
                 <a:spcPct val="115000"/>
@@ -7733,10 +7252,10 @@
                 <a:latin typeface="Consolas"/>
                 <a:ea typeface="Consolas"/>
               </a:rPr>
-              <a:t>│   ├─ master.sh                  运行主控脚本：同步 → 排列 → 提交</a:t>
-            </a:r>
-          </a:p>
-          <a:p xmlns:a="http://schemas.openxmlformats.org/drawingml/2006/main">
+              <a:t>│   ├─ run-pipeline.sh               同步 → 情景展开 → Slurm 提交 → 合并</a:t>
+            </a:r>
+          </a:p>
+          <a:p>
             <a:pPr algn="l">
               <a:lnSpc>
                 <a:spcPct val="115000"/>
@@ -7753,10 +7272,10 @@
                 <a:latin typeface="Consolas"/>
                 <a:ea typeface="Consolas"/>
               </a:rPr>
-              <a:t>│   ├─ build-tools/               编译配置、依赖库 (jars, eigen) 与站点 profile</a:t>
-            </a:r>
-          </a:p>
-          <a:p xmlns:a="http://schemas.openxmlformats.org/drawingml/2006/main">
+              <a:t>│   ├─ run-tools/                    RUN、QUERY 执行与结果合并脚本</a:t>
+            </a:r>
+          </a:p>
+          <a:p>
             <a:pPr algn="l">
               <a:lnSpc>
                 <a:spcPct val="115000"/>
@@ -7773,10 +7292,10 @@
                 <a:latin typeface="Consolas"/>
                 <a:ea typeface="Consolas"/>
               </a:rPr>
-              <a:t>│   ├─ run-tools/                 提交、情景排列 (permutator) 与结果合并脚本</a:t>
-            </a:r>
-          </a:p>
-          <a:p xmlns:a="http://schemas.openxmlformats.org/drawingml/2006/main">
+              <a:t>│   ├─ configuration-sets/           配置模板与 batch XML</a:t>
+            </a:r>
+          </a:p>
+          <a:p>
             <a:pPr algn="l">
               <a:lnSpc>
                 <a:spcPct val="115000"/>
@@ -7793,10 +7312,10 @@
                 <a:latin typeface="Consolas"/>
                 <a:ea typeface="Consolas"/>
               </a:rPr>
-              <a:t>│   ├─ configuration-sets/        默认配置文件与 batch XML 示例</a:t>
-            </a:r>
-          </a:p>
-          <a:p xmlns:a="http://schemas.openxmlformats.org/drawingml/2006/main">
+              <a:t>│   └─ query-tools/</a:t>
+            </a:r>
+          </a:p>
+          <a:p>
             <a:pPr algn="l">
               <a:lnSpc>
                 <a:spcPct val="115000"/>
@@ -7813,10 +7332,10 @@
                 <a:latin typeface="Consolas"/>
                 <a:ea typeface="Consolas"/>
               </a:rPr>
-              <a:t>│   └─ query-tools/               查询生成器与用户查询 XML</a:t>
-            </a:r>
-          </a:p>
-          <a:p xmlns:a="http://schemas.openxmlformats.org/drawingml/2006/main">
+              <a:t>│       ├─ batch_query_generator/    QUERY 生成器</a:t>
+            </a:r>
+          </a:p>
+          <a:p>
             <a:pPr algn="l">
               <a:lnSpc>
                 <a:spcPct val="115000"/>
@@ -7833,7 +7352,47 @@
                 <a:latin typeface="Consolas"/>
                 <a:ea typeface="Consolas"/>
               </a:rPr>
-              <a:t>└─ gcam-scratch/                  运行期临时空间：中间文件与输出</a:t>
+              <a:t>│       └─ user_batch_queries/       本地用户 QUERY XML</a:t>
+            </a:r>
+          </a:p>
+          <a:p>
+            <a:pPr algn="l">
+              <a:lnSpc>
+                <a:spcPct val="115000"/>
+              </a:lnSpc>
+              <a:spcAft>
+                <a:spcPts val="0"/>
+              </a:spcAft>
+            </a:pPr>
+            <a:r>
+              <a:rPr lang="en-US" sz="1350" b="0">
+                <a:solidFill>
+                  <a:srgbClr val="1A1A1A"/>
+                </a:solidFill>
+                <a:latin typeface="Consolas"/>
+                <a:ea typeface="Consolas"/>
+              </a:rPr>
+              <a:t>├─ gcam-runjob-log/                  Slurm 日志</a:t>
+            </a:r>
+          </a:p>
+          <a:p>
+            <a:pPr algn="l">
+              <a:lnSpc>
+                <a:spcPct val="115000"/>
+              </a:lnSpc>
+              <a:spcAft>
+                <a:spcPts val="0"/>
+              </a:spcAft>
+            </a:pPr>
+            <a:r>
+              <a:rPr lang="en-US" sz="1350" b="0">
+                <a:solidFill>
+                  <a:srgbClr val="1A1A1A"/>
+                </a:solidFill>
+                <a:latin typeface="Consolas"/>
+                <a:ea typeface="Consolas"/>
+              </a:rPr>
+              <a:t>└─ gcam-scratch/{input,output}/      运行输入与输出</a:t>
             </a:r>
           </a:p>
         </p:txBody>
@@ -7874,7 +7433,7 @@
                 <a:latin typeface="Arial"/>
                 <a:ea typeface="微软雅黑"/>
               </a:rPr>
-              <a:t>编译期 GCAM_WORKSPACE 与运行期 GCAM_HPC_WORKSPACE 均指向仓库根目录 gcam-hpc-PKU/。</a:t>
+              <a:t>统一 source build-tools/environment.sh；运行产物和用户生成的 queries-*.xml 不上传 GitHub。</a:t>
             </a:r>
           </a:p>
         </p:txBody>
@@ -8013,7 +7572,9 @@
           <a:noFill xmlns:a="http://schemas.openxmlformats.org/drawingml/2006/main"/>
         </p:spPr>
         <p:txBody>
-          <a:bodyPr xmlns:a="http://schemas.openxmlformats.org/drawingml/2006/main" wrap="square" anchor="t"/>
+          <a:bodyPr xmlns:a="http://schemas.openxmlformats.org/drawingml/2006/main" wrap="square" anchor="t">
+            <a:normAutofit/>
+          </a:bodyPr>
           <a:lstStyle xmlns:a="http://schemas.openxmlformats.org/drawingml/2006/main"/>
           <a:p xmlns:a="http://schemas.openxmlformats.org/drawingml/2006/main">
             <a:pPr algn="l">
@@ -8032,7 +7593,7 @@
                 <a:latin typeface="Arial"/>
                 <a:ea typeface="微软雅黑"/>
               </a:rPr>
-              <a:t>1 · 克隆仓库并拉取子模块</a:t>
+              <a:t>1 · 克隆工具仓库</a:t>
             </a:r>
           </a:p>
         </p:txBody>
@@ -8063,7 +7624,7 @@
         <p:txBody>
           <a:bodyPr xmlns:a="http://schemas.openxmlformats.org/drawingml/2006/main" wrap="square" lIns="146304" tIns="146304" rIns="146304" bIns="146304" anchor="t"/>
           <a:lstStyle xmlns:a="http://schemas.openxmlformats.org/drawingml/2006/main"/>
-          <a:p xmlns:a="http://schemas.openxmlformats.org/drawingml/2006/main">
+          <a:p>
             <a:pPr algn="l">
               <a:lnSpc>
                 <a:spcPct val="115000"/>
@@ -8083,7 +7644,7 @@
               <a:t>git clone https://github.com/jerrysong0128/gcam-hpc-PKU.git</a:t>
             </a:r>
           </a:p>
-          <a:p xmlns:a="http://schemas.openxmlformats.org/drawingml/2006/main">
+          <a:p>
             <a:pPr algn="l">
               <a:lnSpc>
                 <a:spcPct val="115000"/>
@@ -8103,26 +7664,6 @@
               <a:t>cd gcam-hpc-PKU</a:t>
             </a:r>
           </a:p>
-          <a:p xmlns:a="http://schemas.openxmlformats.org/drawingml/2006/main">
-            <a:pPr algn="l">
-              <a:lnSpc>
-                <a:spcPct val="115000"/>
-              </a:lnSpc>
-              <a:spcAft>
-                <a:spcPts val="0"/>
-              </a:spcAft>
-            </a:pPr>
-            <a:r>
-              <a:rPr lang="en-US" sz="1350" b="0">
-                <a:solidFill>
-                  <a:srgbClr val="1A1A1A"/>
-                </a:solidFill>
-                <a:latin typeface="Consolas"/>
-                <a:ea typeface="Consolas"/>
-              </a:rPr>
-              <a:t>git submodule update --init --recursive</a:t>
-            </a:r>
-          </a:p>
         </p:txBody>
       </p:sp>
       <p:sp>
@@ -8142,7 +7683,9 @@
           <a:noFill xmlns:a="http://schemas.openxmlformats.org/drawingml/2006/main"/>
         </p:spPr>
         <p:txBody>
-          <a:bodyPr xmlns:a="http://schemas.openxmlformats.org/drawingml/2006/main" wrap="square" anchor="t"/>
+          <a:bodyPr xmlns:a="http://schemas.openxmlformats.org/drawingml/2006/main" wrap="square" anchor="t">
+            <a:normAutofit/>
+          </a:bodyPr>
           <a:lstStyle xmlns:a="http://schemas.openxmlformats.org/drawingml/2006/main"/>
           <a:p xmlns:a="http://schemas.openxmlformats.org/drawingml/2006/main">
             <a:pPr algn="l">
@@ -8161,7 +7704,7 @@
                 <a:latin typeface="Arial"/>
                 <a:ea typeface="微软雅黑"/>
               </a:rPr>
-              <a:t>2 · 获取 GCAM 源码（按 variant 下载；工作区自动识别目录）</a:t>
+              <a:t>2 · 本地下载 GCAM 源码并上传超算</a:t>
             </a:r>
           </a:p>
         </p:txBody>
@@ -8190,7 +7733,9 @@
           </a:ln>
         </p:spPr>
         <p:txBody>
-          <a:bodyPr xmlns:a="http://schemas.openxmlformats.org/drawingml/2006/main" wrap="square" lIns="146304" tIns="146304" rIns="146304" bIns="146304" anchor="t"/>
+          <a:bodyPr xmlns:a="http://schemas.openxmlformats.org/drawingml/2006/main" wrap="square" lIns="146304" tIns="146304" rIns="146304" bIns="146304" anchor="t">
+            <a:normAutofit/>
+          </a:bodyPr>
           <a:lstStyle xmlns:a="http://schemas.openxmlformats.org/drawingml/2006/main"/>
           <a:p>
             <a:pPr algn="l">
@@ -8202,14 +7747,14 @@
               </a:spcAft>
             </a:pPr>
             <a:r>
-              <a:rPr lang="en-US" sz="850" b="0">
+              <a:rPr lang="en-US" sz="1200" b="0">
                 <a:solidFill>
                   <a:srgbClr val="1A1A1A"/>
                 </a:solidFill>
                 <a:latin typeface="Consolas"/>
                 <a:ea typeface="Consolas"/>
               </a:rPr>
-              <a:t>./gcam-hpc-tools/fetch_gcam_source.sh --variant core --version gcam-v9.1   # v9.0/v8.11/v8.2</a:t>
+              <a:t>gcam-core:  github.com/JGCRI/gcam-core/releases</a:t>
             </a:r>
           </a:p>
           <a:p>
@@ -8222,14 +7767,34 @@
               </a:spcAft>
             </a:pPr>
             <a:r>
-              <a:rPr lang="en-US" sz="850" b="0">
+              <a:rPr lang="en-US" sz="1200" b="0">
                 <a:solidFill>
                   <a:srgbClr val="1A1A1A"/>
                 </a:solidFill>
                 <a:latin typeface="Consolas"/>
                 <a:ea typeface="Consolas"/>
               </a:rPr>
-              <a:t>./gcam-hpc-tools/fetch_gcam_source.sh --variant china --version gcam-china-v8   # v7.1/v7/v6</a:t>
+              <a:t>gcam-china: github.com/umd-cgs/gcam-china/releases</a:t>
+            </a:r>
+          </a:p>
+          <a:p>
+            <a:pPr algn="l">
+              <a:lnSpc>
+                <a:spcPct val="115000"/>
+              </a:lnSpc>
+              <a:spcAft>
+                <a:spcPts val="0"/>
+              </a:spcAft>
+            </a:pPr>
+            <a:r>
+              <a:rPr lang="en-US" sz="1200" b="0">
+                <a:solidFill>
+                  <a:srgbClr val="1A1A1A"/>
+                </a:solidFill>
+                <a:latin typeface="Consolas"/>
+                <a:ea typeface="Consolas"/>
+              </a:rPr>
+              <a:t># 上传并解压到仓库根目录；源码须包含 cvs/objects/build/linux</a:t>
             </a:r>
           </a:p>
         </p:txBody>
@@ -8251,7 +7816,9 @@
           <a:noFill xmlns:a="http://schemas.openxmlformats.org/drawingml/2006/main"/>
         </p:spPr>
         <p:txBody>
-          <a:bodyPr xmlns:a="http://schemas.openxmlformats.org/drawingml/2006/main" wrap="square" anchor="t"/>
+          <a:bodyPr xmlns:a="http://schemas.openxmlformats.org/drawingml/2006/main" wrap="square" anchor="t">
+            <a:normAutofit/>
+          </a:bodyPr>
           <a:lstStyle xmlns:a="http://schemas.openxmlformats.org/drawingml/2006/main"/>
           <a:p xmlns:a="http://schemas.openxmlformats.org/drawingml/2006/main">
             <a:pPr algn="l">
@@ -8270,7 +7837,7 @@
                 <a:latin typeface="Arial"/>
                 <a:ea typeface="微软雅黑"/>
               </a:rPr>
-              <a:t>3 · 编辑并 source 工作区设置文件</a:t>
+              <a:t>3 · 解压依赖并加载统一环境</a:t>
             </a:r>
           </a:p>
         </p:txBody>
@@ -8299,9 +7866,11 @@
           </a:ln>
         </p:spPr>
         <p:txBody>
-          <a:bodyPr xmlns:a="http://schemas.openxmlformats.org/drawingml/2006/main" wrap="square" lIns="146304" tIns="146304" rIns="146304" bIns="146304" anchor="t"/>
-          <a:lstStyle xmlns:a="http://schemas.openxmlformats.org/drawingml/2006/main"/>
-          <a:p xmlns:a="http://schemas.openxmlformats.org/drawingml/2006/main">
+          <a:bodyPr xmlns:a="http://schemas.openxmlformats.org/drawingml/2006/main" wrap="square" lIns="146304" tIns="146304" rIns="146304" bIns="146304" anchor="t">
+            <a:normAutofit/>
+          </a:bodyPr>
+          <a:lstStyle xmlns:a="http://schemas.openxmlformats.org/drawingml/2006/main"/>
+          <a:p>
             <a:pPr algn="l">
               <a:lnSpc>
                 <a:spcPct val="115000"/>
@@ -8311,17 +7880,17 @@
               </a:spcAft>
             </a:pPr>
             <a:r>
-              <a:rPr lang="en-US" sz="1350" b="0">
+              <a:rPr lang="en-US" sz="1250" b="0">
                 <a:solidFill>
                   <a:srgbClr val="1A1A1A"/>
                 </a:solidFill>
                 <a:latin typeface="Consolas"/>
                 <a:ea typeface="Consolas"/>
               </a:rPr>
-              <a:t># 编辑 gcam-hpc-tools/gcam_workspace.setup 中两行：</a:t>
-            </a:r>
-          </a:p>
-          <a:p xmlns:a="http://schemas.openxmlformats.org/drawingml/2006/main">
+              <a:t>cd gcam-hpc-tools/build-tools</a:t>
+            </a:r>
+          </a:p>
+          <a:p>
             <a:pPr algn="l">
               <a:lnSpc>
                 <a:spcPct val="115000"/>
@@ -8331,17 +7900,17 @@
               </a:spcAft>
             </a:pPr>
             <a:r>
-              <a:rPr lang="en-US" sz="1350" b="0">
+              <a:rPr lang="en-US" sz="1250" b="0">
                 <a:solidFill>
                   <a:srgbClr val="1A1A1A"/>
                 </a:solidFill>
                 <a:latin typeface="Consolas"/>
                 <a:ea typeface="Consolas"/>
               </a:rPr>
-              <a:t>export GCAM_HPC_WORKSPACE=/absolute/path/to/gcam-hpc-PKU</a:t>
-            </a:r>
-          </a:p>
-          <a:p xmlns:a="http://schemas.openxmlformats.org/drawingml/2006/main">
+              <a:t>unzip gcam-hpc-pku-libs.zip</a:t>
+            </a:r>
+          </a:p>
+          <a:p>
             <a:pPr algn="l">
               <a:lnSpc>
                 <a:spcPct val="115000"/>
@@ -8351,17 +7920,17 @@
               </a:spcAft>
             </a:pPr>
             <a:r>
-              <a:rPr lang="en-US" sz="1350" b="0">
+              <a:rPr lang="en-US" sz="1250" b="0">
                 <a:solidFill>
                   <a:srgbClr val="1A1A1A"/>
                 </a:solidFill>
                 <a:latin typeface="Consolas"/>
                 <a:ea typeface="Consolas"/>
               </a:rPr>
-              <a:t>export GCAM_HPC_CLUSTER=wm2          # 或 wm1 / 自定义 profile</a:t>
-            </a:r>
-          </a:p>
-          <a:p xmlns:a="http://schemas.openxmlformats.org/drawingml/2006/main">
+              <a:t>unzip archive/libs.zip             # 生成 libs/</a:t>
+            </a:r>
+          </a:p>
+          <a:p>
             <a:pPr algn="l">
               <a:lnSpc>
                 <a:spcPct val="115000"/>
@@ -8371,7 +7940,7 @@
               </a:spcAft>
             </a:pPr>
             <a:r>
-              <a:rPr lang="en-US" sz="1350" b="0">
+              <a:rPr lang="en-US" sz="1250" b="0">
                 <a:solidFill>
                   <a:srgbClr val="1A1A1A"/>
                 </a:solidFill>
@@ -8381,7 +7950,7 @@
               <a:t/>
             </a:r>
           </a:p>
-          <a:p xmlns:a="http://schemas.openxmlformats.org/drawingml/2006/main">
+          <a:p>
             <a:pPr algn="l">
               <a:lnSpc>
                 <a:spcPct val="115000"/>
@@ -8391,14 +7960,54 @@
               </a:spcAft>
             </a:pPr>
             <a:r>
-              <a:rPr lang="en-US" sz="1350" b="0">
+              <a:rPr lang="en-US" sz="1250" b="0">
                 <a:solidFill>
                   <a:srgbClr val="1A1A1A"/>
                 </a:solidFill>
                 <a:latin typeface="Consolas"/>
                 <a:ea typeface="Consolas"/>
               </a:rPr>
-              <a:t>source $GCAM_HPC_WORKSPACE/gcam-hpc-tools/gcam_workspace.setup</a:t>
+              <a:t>export GCAM_HPC_WORKSPACE=/absolute/path/to/gcam-hpc-PKU</a:t>
+            </a:r>
+          </a:p>
+          <a:p>
+            <a:pPr algn="l">
+              <a:lnSpc>
+                <a:spcPct val="115000"/>
+              </a:lnSpc>
+              <a:spcAft>
+                <a:spcPts val="0"/>
+              </a:spcAft>
+            </a:pPr>
+            <a:r>
+              <a:rPr lang="en-US" sz="1250" b="0">
+                <a:solidFill>
+                  <a:srgbClr val="1A1A1A"/>
+                </a:solidFill>
+                <a:latin typeface="Consolas"/>
+                <a:ea typeface="Consolas"/>
+              </a:rPr>
+              <a:t>export GCAM_HPC_CLUSTER=wm2</a:t>
+            </a:r>
+          </a:p>
+          <a:p>
+            <a:pPr algn="l">
+              <a:lnSpc>
+                <a:spcPct val="115000"/>
+              </a:lnSpc>
+              <a:spcAft>
+                <a:spcPts val="0"/>
+              </a:spcAft>
+            </a:pPr>
+            <a:r>
+              <a:rPr lang="en-US" sz="1250" b="0">
+                <a:solidFill>
+                  <a:srgbClr val="1A1A1A"/>
+                </a:solidFill>
+                <a:latin typeface="Consolas"/>
+                <a:ea typeface="Consolas"/>
+              </a:rPr>
+              <a:t>source environment.sh</a:t>
             </a:r>
           </a:p>
         </p:txBody>
@@ -8439,7 +8048,7 @@
                 <a:latin typeface="Arial"/>
                 <a:ea typeface="微软雅黑"/>
               </a:rPr>
-              <a:t>source 后一次性导出 GCAMDIR、TOOLDIR、SCRATCHDIR、BOOST_*、JAVA_*、TBB_*、EIGEN_INCLUDE、JARS_LIB、SLURM_TEMPLATE，无需其它 export。</a:t>
+              <a:t>environment.sh 自动识别 gcam-core / gcam-china 源码目录，并加载 profiles/&lt;cluster&gt;.profile。</a:t>
             </a:r>
           </a:p>
         </p:txBody>
@@ -8628,7 +8237,7 @@
                 <a:latin typeface="Arial"/>
                 <a:ea typeface="微软雅黑"/>
               </a:rPr>
-              <a:t>WM2 · 本地依赖</a:t>
+              <a:t>依赖目录</a:t>
             </a:r>
           </a:p>
         </p:txBody>
@@ -8650,9 +8259,11 @@
           <a:noFill xmlns:a="http://schemas.openxmlformats.org/drawingml/2006/main"/>
         </p:spPr>
         <p:txBody>
-          <a:bodyPr xmlns:a="http://schemas.openxmlformats.org/drawingml/2006/main" wrap="square" anchor="t"/>
-          <a:lstStyle xmlns:a="http://schemas.openxmlformats.org/drawingml/2006/main"/>
-          <a:p xmlns:a="http://schemas.openxmlformats.org/drawingml/2006/main">
+          <a:bodyPr xmlns:a="http://schemas.openxmlformats.org/drawingml/2006/main" wrap="square" anchor="t">
+            <a:normAutofit/>
+          </a:bodyPr>
+          <a:lstStyle xmlns:a="http://schemas.openxmlformats.org/drawingml/2006/main"/>
+          <a:p>
             <a:pPr algn="l">
               <a:lnSpc>
                 <a:spcPct val="125000"/>
@@ -8669,10 +8280,10 @@
                 <a:latin typeface="Arial"/>
                 <a:ea typeface="微软雅黑"/>
               </a:rPr>
-              <a:t>gcam-hpc-build-relative-libs-wm2.setup</a:t>
-            </a:r>
-          </a:p>
-          <a:p xmlns:a="http://schemas.openxmlformats.org/drawingml/2006/main">
+              <a:t>build-tools/libs/</a:t>
+            </a:r>
+          </a:p>
+          <a:p>
             <a:pPr algn="l">
               <a:lnSpc>
                 <a:spcPct val="125000"/>
@@ -8689,7 +8300,7 @@
                 <a:latin typeface="Arial"/>
                 <a:ea typeface="微软雅黑"/>
               </a:rPr>
-              <a:t>export GCAM_WORKSPACE=…</a:t>
+              <a:t>boost-lib · eigen · jars · java_linux · tbb-linux</a:t>
             </a:r>
           </a:p>
         </p:txBody>
@@ -8761,7 +8372,7 @@
                 <a:latin typeface="Arial"/>
                 <a:ea typeface="微软雅黑"/>
               </a:rPr>
-              <a:t>WM1 · 共享依赖</a:t>
+              <a:t>集群 profile</a:t>
             </a:r>
           </a:p>
         </p:txBody>
@@ -8783,9 +8394,11 @@
           <a:noFill xmlns:a="http://schemas.openxmlformats.org/drawingml/2006/main"/>
         </p:spPr>
         <p:txBody>
-          <a:bodyPr xmlns:a="http://schemas.openxmlformats.org/drawingml/2006/main" wrap="square" anchor="t"/>
-          <a:lstStyle xmlns:a="http://schemas.openxmlformats.org/drawingml/2006/main"/>
-          <a:p xmlns:a="http://schemas.openxmlformats.org/drawingml/2006/main">
+          <a:bodyPr xmlns:a="http://schemas.openxmlformats.org/drawingml/2006/main" wrap="square" anchor="t">
+            <a:normAutofit/>
+          </a:bodyPr>
+          <a:lstStyle xmlns:a="http://schemas.openxmlformats.org/drawingml/2006/main"/>
+          <a:p>
             <a:pPr algn="l">
               <a:lnSpc>
                 <a:spcPct val="125000"/>
@@ -8802,10 +8415,10 @@
                 <a:latin typeface="Arial"/>
                 <a:ea typeface="微软雅黑"/>
               </a:rPr>
-              <a:t>gcam-hpc-build-shared-libs-wm1.setup</a:t>
-            </a:r>
-          </a:p>
-          <a:p xmlns:a="http://schemas.openxmlformats.org/drawingml/2006/main">
+              <a:t>build-tools/profiles/</a:t>
+            </a:r>
+          </a:p>
+          <a:p>
             <a:pPr algn="l">
               <a:lnSpc>
                 <a:spcPct val="125000"/>
@@ -8822,7 +8435,7 @@
                 <a:latin typeface="Arial"/>
                 <a:ea typeface="微软雅黑"/>
               </a:rPr>
-              <a:t>export GCAM_HPC_PKU_HOME=…</a:t>
+              <a:t>wm1.profile · wm2.profile · custom.profile</a:t>
             </a:r>
           </a:p>
         </p:txBody>
@@ -8863,7 +8476,7 @@
                 <a:latin typeface="Arial"/>
                 <a:ea typeface="微软雅黑"/>
               </a:rPr>
-              <a:t>⚠ 两套配置的路径、模块与分区不同，不可混用。</a:t>
+              <a:t>统一环境脚本选择 profile；不要混用不同集群的 module、partition 与依赖路径。</a:t>
             </a:r>
           </a:p>
         </p:txBody>
@@ -8885,7 +8498,9 @@
           <a:noFill xmlns:a="http://schemas.openxmlformats.org/drawingml/2006/main"/>
         </p:spPr>
         <p:txBody>
-          <a:bodyPr xmlns:a="http://schemas.openxmlformats.org/drawingml/2006/main" wrap="square" anchor="t"/>
+          <a:bodyPr xmlns:a="http://schemas.openxmlformats.org/drawingml/2006/main" wrap="square" anchor="t">
+            <a:normAutofit/>
+          </a:bodyPr>
           <a:lstStyle xmlns:a="http://schemas.openxmlformats.org/drawingml/2006/main"/>
           <a:p xmlns:a="http://schemas.openxmlformats.org/drawingml/2006/main">
             <a:pPr algn="l">
@@ -8904,7 +8519,7 @@
                 <a:latin typeface="Arial"/>
                 <a:ea typeface="微软雅黑"/>
               </a:rPr>
-              <a:t>设置环境并编译（WM2 示例）</a:t>
+              <a:t>加载环境并编译</a:t>
             </a:r>
           </a:p>
         </p:txBody>
@@ -8933,9 +8548,11 @@
           </a:ln>
         </p:spPr>
         <p:txBody>
-          <a:bodyPr xmlns:a="http://schemas.openxmlformats.org/drawingml/2006/main" wrap="square" lIns="146304" tIns="146304" rIns="146304" bIns="146304" anchor="t"/>
-          <a:lstStyle xmlns:a="http://schemas.openxmlformats.org/drawingml/2006/main"/>
-          <a:p xmlns:a="http://schemas.openxmlformats.org/drawingml/2006/main">
+          <a:bodyPr xmlns:a="http://schemas.openxmlformats.org/drawingml/2006/main" wrap="square" lIns="146304" tIns="146304" rIns="146304" bIns="146304" anchor="t">
+            <a:normAutofit/>
+          </a:bodyPr>
+          <a:lstStyle xmlns:a="http://schemas.openxmlformats.org/drawingml/2006/main"/>
+          <a:p>
             <a:pPr algn="l">
               <a:lnSpc>
                 <a:spcPct val="115000"/>
@@ -8945,17 +8562,17 @@
               </a:spcAft>
             </a:pPr>
             <a:r>
-              <a:rPr lang="en-US" sz="1350" b="0">
+              <a:rPr lang="en-US" sz="1250" b="0">
                 <a:solidFill>
                   <a:srgbClr val="1A1A1A"/>
                 </a:solidFill>
                 <a:latin typeface="Consolas"/>
                 <a:ea typeface="Consolas"/>
               </a:rPr>
-              <a:t>export GCAM_WORKSPACE=/path/to/gcam-hpc-PKU</a:t>
-            </a:r>
-          </a:p>
-          <a:p xmlns:a="http://schemas.openxmlformats.org/drawingml/2006/main">
+              <a:t>export GCAM_HPC_WORKSPACE=/path/to/gcam-hpc-PKU</a:t>
+            </a:r>
+          </a:p>
+          <a:p>
             <a:pPr algn="l">
               <a:lnSpc>
                 <a:spcPct val="115000"/>
@@ -8965,17 +8582,17 @@
               </a:spcAft>
             </a:pPr>
             <a:r>
-              <a:rPr lang="en-US" sz="1350" b="0">
+              <a:rPr lang="en-US" sz="1250" b="0">
                 <a:solidFill>
                   <a:srgbClr val="1A1A1A"/>
                 </a:solidFill>
                 <a:latin typeface="Consolas"/>
                 <a:ea typeface="Consolas"/>
               </a:rPr>
-              <a:t>source gcam-hpc-tools/build-tools/gcam-hpc-build-relative-libs-wm2.setup</a:t>
-            </a:r>
-          </a:p>
-          <a:p xmlns:a="http://schemas.openxmlformats.org/drawingml/2006/main">
+              <a:t>export GCAM_HPC_CLUSTER=wm2</a:t>
+            </a:r>
+          </a:p>
+          <a:p>
             <a:pPr algn="l">
               <a:lnSpc>
                 <a:spcPct val="115000"/>
@@ -8985,17 +8602,17 @@
               </a:spcAft>
             </a:pPr>
             <a:r>
-              <a:rPr lang="en-US" sz="1350" b="0">
+              <a:rPr lang="en-US" sz="1250" b="0">
                 <a:solidFill>
                   <a:srgbClr val="1A1A1A"/>
                 </a:solidFill>
                 <a:latin typeface="Consolas"/>
                 <a:ea typeface="Consolas"/>
               </a:rPr>
-              <a:t>cd gcam-core</a:t>
-            </a:r>
-          </a:p>
-          <a:p xmlns:a="http://schemas.openxmlformats.org/drawingml/2006/main">
+              <a:t>source gcam-hpc-tools/build-tools/environment.sh</a:t>
+            </a:r>
+          </a:p>
+          <a:p>
             <a:pPr algn="l">
               <a:lnSpc>
                 <a:spcPct val="115000"/>
@@ -9005,17 +8622,17 @@
               </a:spcAft>
             </a:pPr>
             <a:r>
-              <a:rPr lang="en-US" sz="1350" b="0">
+              <a:rPr lang="en-US" sz="1250" b="0">
                 <a:solidFill>
                   <a:srgbClr val="1A1A1A"/>
                 </a:solidFill>
                 <a:latin typeface="Consolas"/>
                 <a:ea typeface="Consolas"/>
               </a:rPr>
-              <a:t>make clean</a:t>
-            </a:r>
-          </a:p>
-          <a:p xmlns:a="http://schemas.openxmlformats.org/drawingml/2006/main">
+              <a:t>cd "$GCAM_LIB"</a:t>
+            </a:r>
+          </a:p>
+          <a:p>
             <a:pPr algn="l">
               <a:lnSpc>
                 <a:spcPct val="115000"/>
@@ -9025,14 +8642,34 @@
               </a:spcAft>
             </a:pPr>
             <a:r>
-              <a:rPr lang="en-US" sz="1350" b="0">
+              <a:rPr lang="en-US" sz="1250" b="0">
                 <a:solidFill>
                   <a:srgbClr val="1A1A1A"/>
                 </a:solidFill>
                 <a:latin typeface="Consolas"/>
                 <a:ea typeface="Consolas"/>
               </a:rPr>
-              <a:t>make gcam -j 8                # -j 依 CPU 配额调整</a:t>
+              <a:t>make clean</a:t>
+            </a:r>
+          </a:p>
+          <a:p>
+            <a:pPr algn="l">
+              <a:lnSpc>
+                <a:spcPct val="115000"/>
+              </a:lnSpc>
+              <a:spcAft>
+                <a:spcPts val="0"/>
+              </a:spcAft>
+            </a:pPr>
+            <a:r>
+              <a:rPr lang="en-US" sz="1250" b="0">
+                <a:solidFill>
+                  <a:srgbClr val="1A1A1A"/>
+                </a:solidFill>
+                <a:latin typeface="Consolas"/>
+                <a:ea typeface="Consolas"/>
+              </a:rPr>
+              <a:t>make gcam -j 16</a:t>
             </a:r>
           </a:p>
         </p:txBody>
@@ -9054,7 +8691,9 @@
           <a:noFill xmlns:a="http://schemas.openxmlformats.org/drawingml/2006/main"/>
         </p:spPr>
         <p:txBody>
-          <a:bodyPr xmlns:a="http://schemas.openxmlformats.org/drawingml/2006/main" wrap="square" anchor="t"/>
+          <a:bodyPr xmlns:a="http://schemas.openxmlformats.org/drawingml/2006/main" wrap="square" anchor="t">
+            <a:normAutofit/>
+          </a:bodyPr>
           <a:lstStyle xmlns:a="http://schemas.openxmlformats.org/drawingml/2006/main"/>
           <a:p xmlns:a="http://schemas.openxmlformats.org/drawingml/2006/main">
             <a:pPr algn="l">
@@ -9114,7 +8753,7 @@
                 <a:latin typeface="Arial"/>
                 <a:ea typeface="微软雅黑"/>
               </a:rPr>
-              <a:t>gcam-core/exe/gcam.exe 存在  ·  make 打印 BUILD COMPLETED  ·  cvs/objects/build/linux 无新增错误</a:t>
+              <a:t>编译退出码为 0  ·  源码 exe/gcam.exe 已生成  ·  GCAMDIR / GCAM_LIB / TOOLDIR 指向预期目录</a:t>
             </a:r>
           </a:p>
         </p:txBody>
@@ -9170,7 +8809,7 @@
                 <a:latin typeface="Arial"/>
                 <a:ea typeface="微软雅黑"/>
               </a:rPr>
-              <a:t>② RUN：用 master.sh 提交作业</a:t>
+              <a:t>② RUN：用 run-pipeline.sh 提交作业</a:t>
             </a:r>
           </a:p>
         </p:txBody>
@@ -9253,7 +8892,9 @@
           <a:noFill xmlns:a="http://schemas.openxmlformats.org/drawingml/2006/main"/>
         </p:spPr>
         <p:txBody>
-          <a:bodyPr xmlns:a="http://schemas.openxmlformats.org/drawingml/2006/main" wrap="square" anchor="t"/>
+          <a:bodyPr xmlns:a="http://schemas.openxmlformats.org/drawingml/2006/main" wrap="square" anchor="t">
+            <a:normAutofit/>
+          </a:bodyPr>
           <a:lstStyle xmlns:a="http://schemas.openxmlformats.org/drawingml/2006/main"/>
           <a:p xmlns:a="http://schemas.openxmlformats.org/drawingml/2006/main">
             <a:pPr algn="l">
@@ -9320,7 +8961,7 @@
                 <a:latin typeface="Consolas"/>
                 <a:ea typeface="Consolas"/>
               </a:rPr>
-              <a:t>test -f gcam-hpc-tools/query-tools/user_batch_queries/xmldb_batch.xml</a:t>
+              <a:t>test -f gcam-hpc-tools/query-tools/user_batch_queries/modelinterface-batch.xml</a:t>
             </a:r>
           </a:p>
           <a:p>
@@ -9340,7 +8981,7 @@
                 <a:latin typeface="Consolas"/>
                 <a:ea typeface="Consolas"/>
               </a:rPr>
-              <a:t># 确认其中 &lt;queryFile&gt; 指向已生成的 output_queries_*.xml</a:t>
+              <a:t># 确认 &lt;queryFile&gt; 指向已生成的 queries-*.xml</a:t>
             </a:r>
           </a:p>
         </p:txBody>
@@ -9362,7 +9003,9 @@
           <a:noFill xmlns:a="http://schemas.openxmlformats.org/drawingml/2006/main"/>
         </p:spPr>
         <p:txBody>
-          <a:bodyPr xmlns:a="http://schemas.openxmlformats.org/drawingml/2006/main" wrap="square" anchor="t"/>
+          <a:bodyPr xmlns:a="http://schemas.openxmlformats.org/drawingml/2006/main" wrap="square" anchor="t">
+            <a:normAutofit/>
+          </a:bodyPr>
           <a:lstStyle xmlns:a="http://schemas.openxmlformats.org/drawingml/2006/main"/>
           <a:p xmlns:a="http://schemas.openxmlformats.org/drawingml/2006/main">
             <a:pPr algn="l">
@@ -9410,9 +9053,11 @@
           </a:ln>
         </p:spPr>
         <p:txBody>
-          <a:bodyPr xmlns:a="http://schemas.openxmlformats.org/drawingml/2006/main" wrap="square" lIns="146304" tIns="146304" rIns="146304" bIns="146304" anchor="t"/>
-          <a:lstStyle xmlns:a="http://schemas.openxmlformats.org/drawingml/2006/main"/>
-          <a:p xmlns:a="http://schemas.openxmlformats.org/drawingml/2006/main">
+          <a:bodyPr xmlns:a="http://schemas.openxmlformats.org/drawingml/2006/main" wrap="square" lIns="146304" tIns="146304" rIns="146304" bIns="146304" anchor="t">
+            <a:normAutofit/>
+          </a:bodyPr>
+          <a:lstStyle xmlns:a="http://schemas.openxmlformats.org/drawingml/2006/main"/>
+          <a:p>
             <a:pPr algn="l">
               <a:lnSpc>
                 <a:spcPct val="115000"/>
@@ -9422,17 +9067,17 @@
               </a:spcAft>
             </a:pPr>
             <a:r>
-              <a:rPr lang="en-US" sz="1300" b="0">
+              <a:rPr lang="en-US" sz="1150" b="0">
                 <a:solidFill>
                   <a:srgbClr val="1A1A1A"/>
                 </a:solidFill>
                 <a:latin typeface="Consolas"/>
                 <a:ea typeface="Consolas"/>
               </a:rPr>
-              <a:t>bash gcam-hpc-tools/master.sh \</a:t>
-            </a:r>
-          </a:p>
-          <a:p xmlns:a="http://schemas.openxmlformats.org/drawingml/2006/main">
+              <a:t>source gcam-hpc-tools/build-tools/environment.sh</a:t>
+            </a:r>
+          </a:p>
+          <a:p>
             <a:pPr algn="l">
               <a:lnSpc>
                 <a:spcPct val="115000"/>
@@ -9442,17 +9087,17 @@
               </a:spcAft>
             </a:pPr>
             <a:r>
-              <a:rPr lang="en-US" sz="1300" b="0">
+              <a:rPr lang="en-US" sz="1150" b="0">
                 <a:solidFill>
                   <a:srgbClr val="1A1A1A"/>
                 </a:solidFill>
                 <a:latin typeface="Consolas"/>
                 <a:ea typeface="Consolas"/>
               </a:rPr>
-              <a:t>  configuration-sets/config/v82_default/v82_default_scenario_components.xml \</a:t>
-            </a:r>
-          </a:p>
-          <a:p xmlns:a="http://schemas.openxmlformats.org/drawingml/2006/main">
+              <a:t>"$TOOLDIR/run-pipeline.sh" \</a:t>
+            </a:r>
+          </a:p>
+          <a:p>
             <a:pPr algn="l">
               <a:lnSpc>
                 <a:spcPct val="115000"/>
@@ -9462,14 +9107,34 @@
               </a:spcAft>
             </a:pPr>
             <a:r>
-              <a:rPr lang="en-US" sz="1300" b="0">
+              <a:rPr lang="en-US" sz="1150" b="0">
                 <a:solidFill>
                   <a:srgbClr val="1A1A1A"/>
                 </a:solidFill>
                 <a:latin typeface="Consolas"/>
                 <a:ea typeface="Consolas"/>
               </a:rPr>
-              <a:t>  configuration-sets/config/v82_default/v82_default_batch_2.xml</a:t>
+              <a:t xml:space="preserve">  "$TOOLDIR/configuration-sets/config/v82_default/v82_default_scenario_components.xml" \</a:t>
+            </a:r>
+          </a:p>
+          <a:p>
+            <a:pPr algn="l">
+              <a:lnSpc>
+                <a:spcPct val="115000"/>
+              </a:lnSpc>
+              <a:spcAft>
+                <a:spcPts val="0"/>
+              </a:spcAft>
+            </a:pPr>
+            <a:r>
+              <a:rPr lang="en-US" sz="1150" b="0">
+                <a:solidFill>
+                  <a:srgbClr val="1A1A1A"/>
+                </a:solidFill>
+                <a:latin typeface="Consolas"/>
+                <a:ea typeface="Consolas"/>
+              </a:rPr>
+              <a:t xml:space="preserve">  "$TOOLDIR/configuration-sets/config/v82_default/v82_default_batch_2.xml"</a:t>
             </a:r>
           </a:p>
         </p:txBody>
@@ -9491,7 +9156,9 @@
           <a:noFill xmlns:a="http://schemas.openxmlformats.org/drawingml/2006/main"/>
         </p:spPr>
         <p:txBody>
-          <a:bodyPr xmlns:a="http://schemas.openxmlformats.org/drawingml/2006/main" wrap="square" anchor="t"/>
+          <a:bodyPr xmlns:a="http://schemas.openxmlformats.org/drawingml/2006/main" wrap="square" anchor="t">
+            <a:normAutofit/>
+          </a:bodyPr>
           <a:lstStyle xmlns:a="http://schemas.openxmlformats.org/drawingml/2006/main"/>
           <a:p xmlns:a="http://schemas.openxmlformats.org/drawingml/2006/main">
             <a:pPr algn="l">
@@ -9510,7 +9177,7 @@
                 <a:latin typeface="Arial"/>
                 <a:ea typeface="微软雅黑"/>
               </a:rPr>
-              <a:t>3 · master.sh 交互式询问三个问题</a:t>
+              <a:t>3 · run-pipeline.sh 交互式确认</a:t>
             </a:r>
           </a:p>
         </p:txBody>
@@ -9863,7 +9530,9 @@
           <a:noFill xmlns:a="http://schemas.openxmlformats.org/drawingml/2006/main"/>
         </p:spPr>
         <p:txBody>
-          <a:bodyPr xmlns:a="http://schemas.openxmlformats.org/drawingml/2006/main" wrap="square" anchor="t"/>
+          <a:bodyPr xmlns:a="http://schemas.openxmlformats.org/drawingml/2006/main" wrap="square" anchor="t">
+            <a:normAutofit/>
+          </a:bodyPr>
           <a:lstStyle xmlns:a="http://schemas.openxmlformats.org/drawingml/2006/main"/>
           <a:p xmlns:a="http://schemas.openxmlformats.org/drawingml/2006/main">
             <a:pPr algn="ctr">
@@ -9882,7 +9551,7 @@
                 <a:latin typeface="Arial"/>
                 <a:ea typeface="微软雅黑"/>
               </a:rPr>
-              <a:t>gcam-core/input 与 user_batch_queries 同步到 scratch</a:t>
+              <a:t>GCAM input 与 user_batch_queries 同步到 scratch</a:t>
             </a:r>
           </a:p>
         </p:txBody>
@@ -9904,7 +9573,9 @@
           <a:noFill xmlns:a="http://schemas.openxmlformats.org/drawingml/2006/main"/>
         </p:spPr>
         <p:txBody>
-          <a:bodyPr xmlns:a="http://schemas.openxmlformats.org/drawingml/2006/main" wrap="square" anchor="ctr"/>
+          <a:bodyPr xmlns:a="http://schemas.openxmlformats.org/drawingml/2006/main" wrap="square" anchor="ctr">
+            <a:normAutofit/>
+          </a:bodyPr>
           <a:lstStyle xmlns:a="http://schemas.openxmlformats.org/drawingml/2006/main"/>
           <a:p xmlns:a="http://schemas.openxmlformats.org/drawingml/2006/main">
             <a:pPr algn="ctr">
@@ -10077,7 +9748,7 @@
                 <a:latin typeface="Arial"/>
                 <a:ea typeface="微软雅黑"/>
               </a:rPr>
-              <a:t>permutator.sh 由 batch XML 展开每个情景的配置</a:t>
+              <a:t>generate-scenarios.sh 展开每个情景配置</a:t>
             </a:r>
           </a:p>
         </p:txBody>
@@ -10099,7 +9770,9 @@
           <a:noFill xmlns:a="http://schemas.openxmlformats.org/drawingml/2006/main"/>
         </p:spPr>
         <p:txBody>
-          <a:bodyPr xmlns:a="http://schemas.openxmlformats.org/drawingml/2006/main" wrap="square" anchor="ctr"/>
+          <a:bodyPr xmlns:a="http://schemas.openxmlformats.org/drawingml/2006/main" wrap="square" anchor="ctr">
+            <a:normAutofit/>
+          </a:bodyPr>
           <a:lstStyle xmlns:a="http://schemas.openxmlformats.org/drawingml/2006/main"/>
           <a:p xmlns:a="http://schemas.openxmlformats.org/drawingml/2006/main">
             <a:pPr algn="ctr">
@@ -10272,7 +9945,7 @@
                 <a:latin typeface="Arial"/>
                 <a:ea typeface="微软雅黑"/>
               </a:rPr>
-              <a:t>按 run-template 模板生成 gcam.slurm</a:t>
+              <a:t>按 profile 模板生成 generated-run.slurm</a:t>
             </a:r>
           </a:p>
         </p:txBody>
@@ -10294,7 +9967,9 @@
           <a:noFill xmlns:a="http://schemas.openxmlformats.org/drawingml/2006/main"/>
         </p:spPr>
         <p:txBody>
-          <a:bodyPr xmlns:a="http://schemas.openxmlformats.org/drawingml/2006/main" wrap="square" anchor="ctr"/>
+          <a:bodyPr xmlns:a="http://schemas.openxmlformats.org/drawingml/2006/main" wrap="square" anchor="ctr">
+            <a:normAutofit/>
+          </a:bodyPr>
           <a:lstStyle xmlns:a="http://schemas.openxmlformats.org/drawingml/2006/main"/>
           <a:p xmlns:a="http://schemas.openxmlformats.org/drawingml/2006/main">
             <a:pPr algn="ctr">
@@ -10489,7 +10164,9 @@
           <a:noFill xmlns:a="http://schemas.openxmlformats.org/drawingml/2006/main"/>
         </p:spPr>
         <p:txBody>
-          <a:bodyPr xmlns:a="http://schemas.openxmlformats.org/drawingml/2006/main" wrap="square" anchor="ctr"/>
+          <a:bodyPr xmlns:a="http://schemas.openxmlformats.org/drawingml/2006/main" wrap="square" anchor="ctr">
+            <a:normAutofit/>
+          </a:bodyPr>
           <a:lstStyle xmlns:a="http://schemas.openxmlformats.org/drawingml/2006/main"/>
           <a:p xmlns:a="http://schemas.openxmlformats.org/drawingml/2006/main">
             <a:pPr algn="ctr">
@@ -10684,7 +10361,9 @@
           <a:noFill xmlns:a="http://schemas.openxmlformats.org/drawingml/2006/main"/>
         </p:spPr>
         <p:txBody>
-          <a:bodyPr xmlns:a="http://schemas.openxmlformats.org/drawingml/2006/main" wrap="square" anchor="t"/>
+          <a:bodyPr xmlns:a="http://schemas.openxmlformats.org/drawingml/2006/main" wrap="square" anchor="t">
+            <a:normAutofit/>
+          </a:bodyPr>
           <a:lstStyle xmlns:a="http://schemas.openxmlformats.org/drawingml/2006/main"/>
           <a:p xmlns:a="http://schemas.openxmlformats.org/drawingml/2006/main">
             <a:pPr algn="l">
@@ -10727,7 +10406,7 @@
         <p:txBody>
           <a:bodyPr xmlns:a="http://schemas.openxmlformats.org/drawingml/2006/main" wrap="square" anchor="t"/>
           <a:lstStyle xmlns:a="http://schemas.openxmlformats.org/drawingml/2006/main"/>
-          <a:p xmlns:a="http://schemas.openxmlformats.org/drawingml/2006/main">
+          <a:p>
             <a:pPr algn="l">
               <a:lnSpc>
                 <a:spcPct val="140000"/>
@@ -10744,10 +10423,10 @@
                 <a:latin typeface="Arial"/>
                 <a:ea typeface="微软雅黑"/>
               </a:rPr>
-              <a:t>• 每个情景均执行一次 gcam.exe，随后执行同一份 xmldb_batch.xml 中预先写好的 QUERY</a:t>
-            </a:r>
-          </a:p>
-          <a:p xmlns:a="http://schemas.openxmlformats.org/drawingml/2006/main">
+              <a:t>• 每个情景执行 gcam.exe，随后执行 modelinterface-batch.xml 中预配置的 QUERY</a:t>
+            </a:r>
+          </a:p>
+          <a:p>
             <a:pPr algn="l">
               <a:lnSpc>
                 <a:spcPct val="140000"/>
@@ -10764,7 +10443,7 @@
                 <a:latin typeface="Arial"/>
                 <a:ea typeface="微软雅黑"/>
               </a:rPr>
-              <a:t>• master.sh 以 afterok 依赖提交 cat_queries.sh；全部情景成功后自动汇总为一个 CSV</a:t>
+              <a:t>• run-pipeline.sh 以 afterok 依赖提交 merge-query-results.sh，最终汇总为一个 CSV</a:t>
             </a:r>
           </a:p>
         </p:txBody>
@@ -10786,7 +10465,9 @@
           <a:noFill xmlns:a="http://schemas.openxmlformats.org/drawingml/2006/main"/>
         </p:spPr>
         <p:txBody>
-          <a:bodyPr xmlns:a="http://schemas.openxmlformats.org/drawingml/2006/main" wrap="square" anchor="t"/>
+          <a:bodyPr xmlns:a="http://schemas.openxmlformats.org/drawingml/2006/main" wrap="square" anchor="t">
+            <a:normAutofit/>
+          </a:bodyPr>
           <a:lstStyle xmlns:a="http://schemas.openxmlformats.org/drawingml/2006/main"/>
           <a:p xmlns:a="http://schemas.openxmlformats.org/drawingml/2006/main">
             <a:pPr algn="l">
@@ -10834,9 +10515,11 @@
           </a:ln>
         </p:spPr>
         <p:txBody>
-          <a:bodyPr xmlns:a="http://schemas.openxmlformats.org/drawingml/2006/main" wrap="square" lIns="146304" tIns="146304" rIns="146304" bIns="146304" anchor="t"/>
-          <a:lstStyle xmlns:a="http://schemas.openxmlformats.org/drawingml/2006/main"/>
-          <a:p xmlns:a="http://schemas.openxmlformats.org/drawingml/2006/main">
+          <a:bodyPr xmlns:a="http://schemas.openxmlformats.org/drawingml/2006/main" wrap="square" lIns="146304" tIns="146304" rIns="146304" bIns="146304" anchor="t">
+            <a:normAutofit/>
+          </a:bodyPr>
+          <a:lstStyle xmlns:a="http://schemas.openxmlformats.org/drawingml/2006/main"/>
+          <a:p>
             <a:pPr algn="l">
               <a:lnSpc>
                 <a:spcPct val="115000"/>
@@ -10853,10 +10536,10 @@
                 <a:latin typeface="Consolas"/>
                 <a:ea typeface="Consolas"/>
               </a:rPr>
-              <a:t>squeue -u $(whoami)                      # 直接查看 Slurm 队列</a:t>
-            </a:r>
-          </a:p>
-          <a:p xmlns:a="http://schemas.openxmlformats.org/drawingml/2006/main">
+              <a:t>squeue -u $(whoami)</a:t>
+            </a:r>
+          </a:p>
+          <a:p>
             <a:pPr algn="l">
               <a:lnSpc>
                 <a:spcPct val="115000"/>
@@ -10873,7 +10556,7 @@
                 <a:latin typeface="Consolas"/>
                 <a:ea typeface="Consolas"/>
               </a:rPr>
-              <a:t>bash gcam-hpc-tools/run-tools/watch_pbs.sh   # 轮询脚本</a:t>
+              <a:t>bash gcam-hpc-tools/run-tools/monitor-jobs.sh</a:t>
             </a:r>
           </a:p>
         </p:txBody>

</xml_diff>